<commit_message>
Regenerate all 8 K2 Produktivitas Kantor PPTs per brand style spec
- Rebuilt from scratch following belajarclaude-pptx-style-spec.md exactly:
  Helvetica font, navy/purple palette, header bar pattern, component library
- All content preserved from original decks (verified via markitdown extraction)
- Fixed the overlapping/overflowing dark template box on M02 slide 3
  (root cause: line-height estimator didn't account for explicit newlines
  and LibreOffice/PowerPoint rendering runs ~18% taller than naive estimate
  — both now fixed in the shared component library with auto-sizing containers)
- Renamed M01 preview file to match M02-M08 naming convention
- QA: validated non-corrupt, placeholder-swept, and every slide visually
  inspected via LibreOffice PDF render for overlap/overflow
</commit_message>
<xml_diff>
--- a/K2-Produktivitas/M03-Gmail-Claude/K2-M03-Gmail-Claude.pptx
+++ b/K2-Produktivitas/M03-Gmail-Claude/K2-M03-Gmail-Claude.pptx
@@ -1121,6 +1121,13 @@
 <file path=ppt/slides/slide1.xml><?xml version="1.0" encoding="utf-8"?>
 <p:sld xmlns:a="http://schemas.openxmlformats.org/drawingml/2006/main" xmlns:r="http://schemas.openxmlformats.org/officeDocument/2006/relationships" xmlns:p="http://schemas.openxmlformats.org/presentationml/2006/main">
   <p:cSld name="Slide 1">
+    <p:bg>
+      <p:bgPr>
+        <a:solidFill>
+          <a:srgbClr val="0D1321"/>
+        </a:solidFill>
+      </p:bgPr>
+    </p:bg>
     <p:spTree>
       <p:nvGrpSpPr>
         <p:cNvPr id="1" name=""/>
@@ -1143,28 +1150,8 @@
         </p:nvSpPr>
         <p:spPr>
           <a:xfrm>
-            <a:off x="0" y="0"/>
-            <a:ext cx="12191695" cy="6858000"/>
-          </a:xfrm>
-          <a:prstGeom prst="rect">
-            <a:avLst/>
-          </a:prstGeom>
-          <a:solidFill>
-            <a:srgbClr val="0D1321"/>
-          </a:solidFill>
-          <a:ln/>
-        </p:spPr>
-      </p:sp>
-      <p:sp>
-        <p:nvSpPr>
-          <p:cNvPr id="3" name="Shape 1"/>
-          <p:cNvSpPr/>
-          <p:nvPr/>
-        </p:nvSpPr>
-        <p:spPr>
-          <a:xfrm>
-            <a:off x="8138160" y="0"/>
-            <a:ext cx="4053535" cy="6858000"/>
+            <a:off x="7558851" y="0"/>
+            <a:ext cx="4632844" cy="6858000"/>
           </a:xfrm>
           <a:prstGeom prst="rect">
             <a:avLst/>
@@ -1177,14 +1164,14 @@
       </p:sp>
       <p:sp>
         <p:nvSpPr>
-          <p:cNvPr id="4" name="Text 2"/>
-          <p:cNvSpPr/>
-          <p:nvPr/>
-        </p:nvSpPr>
-        <p:spPr>
-          <a:xfrm>
-            <a:off x="502920" y="411480"/>
-            <a:ext cx="3657600" cy="502920"/>
+          <p:cNvPr id="3" name="Text 1"/>
+          <p:cNvSpPr/>
+          <p:nvPr/>
+        </p:nvSpPr>
+        <p:spPr>
+          <a:xfrm>
+            <a:off x="548640" y="457200"/>
+            <a:ext cx="3657600" cy="457200"/>
           </a:xfrm>
           <a:prstGeom prst="rect">
             <a:avLst/>
@@ -1200,13 +1187,13 @@
               <a:buNone/>
             </a:pPr>
             <a:r>
-              <a:rPr lang="en-US" sz="2200" b="1" dirty="0">
+              <a:rPr lang="en-US" sz="2000" b="1" dirty="0">
                 <a:solidFill>
                   <a:srgbClr val="FFFFFF"/>
                 </a:solidFill>
-                <a:latin typeface="Arial" pitchFamily="34" charset="0"/>
-                <a:ea typeface="Arial" pitchFamily="34" charset="-122"/>
-                <a:cs typeface="Arial" pitchFamily="34" charset="-120"/>
+                <a:latin typeface="Helvetica" pitchFamily="34" charset="0"/>
+                <a:ea typeface="Helvetica" pitchFamily="34" charset="-122"/>
+                <a:cs typeface="Helvetica" pitchFamily="34" charset="-120"/>
               </a:rPr>
               <a:t>belajar</a:t>
             </a:r>
@@ -1214,34 +1201,34 @@
               <a:buNone/>
             </a:pPr>
             <a:r>
-              <a:rPr lang="en-US" sz="2200" b="1" dirty="0">
+              <a:rPr lang="en-US" sz="2000" b="1" dirty="0">
                 <a:solidFill>
                   <a:srgbClr val="8B7CF6"/>
                 </a:solidFill>
-                <a:latin typeface="Arial" pitchFamily="34" charset="0"/>
-                <a:ea typeface="Arial" pitchFamily="34" charset="-122"/>
-                <a:cs typeface="Arial" pitchFamily="34" charset="-120"/>
+                <a:latin typeface="Helvetica" pitchFamily="34" charset="0"/>
+                <a:ea typeface="Helvetica" pitchFamily="34" charset="-122"/>
+                <a:cs typeface="Helvetica" pitchFamily="34" charset="-120"/>
               </a:rPr>
               <a:t>claude</a:t>
             </a:r>
-            <a:endParaRPr lang="en-US" sz="2200" dirty="0"/>
-          </a:p>
-        </p:txBody>
-      </p:sp>
-      <p:sp>
-        <p:nvSpPr>
-          <p:cNvPr id="5" name="Shape 3"/>
-          <p:cNvSpPr/>
-          <p:nvPr/>
-        </p:nvSpPr>
-        <p:spPr>
-          <a:xfrm>
-            <a:off x="9829800" y="347472"/>
-            <a:ext cx="1965960" cy="420624"/>
+            <a:endParaRPr lang="en-US" sz="2000" dirty="0"/>
+          </a:p>
+        </p:txBody>
+      </p:sp>
+      <p:sp>
+        <p:nvSpPr>
+          <p:cNvPr id="4" name="Shape 2"/>
+          <p:cNvSpPr/>
+          <p:nvPr/>
+        </p:nvSpPr>
+        <p:spPr>
+          <a:xfrm>
+            <a:off x="10618927" y="384048"/>
+            <a:ext cx="1024128" cy="384048"/>
           </a:xfrm>
           <a:prstGeom prst="roundRect">
             <a:avLst>
-              <a:gd name="adj" fmla="val 21739"/>
+              <a:gd name="adj" fmla="val 23810"/>
             </a:avLst>
           </a:prstGeom>
           <a:solidFill>
@@ -1252,14 +1239,53 @@
       </p:sp>
       <p:sp>
         <p:nvSpPr>
+          <p:cNvPr id="5" name="Text 3"/>
+          <p:cNvSpPr/>
+          <p:nvPr/>
+        </p:nvSpPr>
+        <p:spPr>
+          <a:xfrm>
+            <a:off x="10618927" y="384048"/>
+            <a:ext cx="1024128" cy="384048"/>
+          </a:xfrm>
+          <a:prstGeom prst="rect">
+            <a:avLst/>
+          </a:prstGeom>
+          <a:noFill/>
+          <a:ln/>
+        </p:spPr>
+        <p:txBody>
+          <a:bodyPr wrap="square" lIns="0" tIns="0" rIns="0" bIns="0" rtlCol="0" anchor="ctr"/>
+          <a:lstStyle/>
+          <a:p>
+            <a:pPr algn="ctr" indent="0" marL="0">
+              <a:buNone/>
+            </a:pPr>
+            <a:r>
+              <a:rPr lang="en-US" sz="1250" b="1" dirty="0">
+                <a:solidFill>
+                  <a:srgbClr val="FFFFFF"/>
+                </a:solidFill>
+                <a:latin typeface="Helvetica" pitchFamily="34" charset="0"/>
+                <a:ea typeface="Helvetica" pitchFamily="34" charset="-122"/>
+                <a:cs typeface="Helvetica" pitchFamily="34" charset="-120"/>
+              </a:rPr>
+              <a:t>MODUL 3</a:t>
+            </a:r>
+            <a:endParaRPr lang="en-US" sz="1250" dirty="0"/>
+          </a:p>
+        </p:txBody>
+      </p:sp>
+      <p:sp>
+        <p:nvSpPr>
           <p:cNvPr id="6" name="Text 4"/>
           <p:cNvSpPr/>
           <p:nvPr/>
         </p:nvSpPr>
         <p:spPr>
           <a:xfrm>
-            <a:off x="9829800" y="347472"/>
-            <a:ext cx="1965960" cy="420624"/>
+            <a:off x="548640" y="2331720"/>
+            <a:ext cx="7772400" cy="320040"/>
           </a:xfrm>
           <a:prstGeom prst="rect">
             <a:avLst/>
@@ -1271,21 +1297,21 @@
           <a:bodyPr wrap="square" lIns="0" tIns="0" rIns="0" bIns="0" rtlCol="0" anchor="ctr"/>
           <a:lstStyle/>
           <a:p>
-            <a:pPr algn="ctr" indent="0" marL="0">
-              <a:buNone/>
-            </a:pPr>
-            <a:r>
-              <a:rPr lang="en-US" sz="1200" b="1" dirty="0">
-                <a:solidFill>
-                  <a:srgbClr val="FFFFFF"/>
-                </a:solidFill>
-                <a:latin typeface="Arial" pitchFamily="34" charset="0"/>
-                <a:ea typeface="Arial" pitchFamily="34" charset="-122"/>
-                <a:cs typeface="Arial" pitchFamily="34" charset="-120"/>
-              </a:rPr>
-              <a:t>MODUL 03</a:t>
-            </a:r>
-            <a:endParaRPr lang="en-US" sz="1200" dirty="0"/>
+            <a:pPr indent="0" marL="0">
+              <a:buNone/>
+            </a:pPr>
+            <a:r>
+              <a:rPr lang="en-US" sz="1300" b="1" spc="40" kern="0" dirty="0">
+                <a:solidFill>
+                  <a:srgbClr val="8B7CF6"/>
+                </a:solidFill>
+                <a:latin typeface="Helvetica" pitchFamily="34" charset="0"/>
+                <a:ea typeface="Helvetica" pitchFamily="34" charset="-122"/>
+                <a:cs typeface="Helvetica" pitchFamily="34" charset="-120"/>
+              </a:rPr>
+              <a:t>PRODUKTIVITAS KANTOR</a:t>
+            </a:r>
+            <a:endParaRPr lang="en-US" sz="1300" dirty="0"/>
           </a:p>
         </p:txBody>
       </p:sp>
@@ -1297,17 +1323,17 @@
         </p:nvSpPr>
         <p:spPr>
           <a:xfrm>
-            <a:off x="502920" y="2286000"/>
-            <a:ext cx="7315200" cy="1371600"/>
-          </a:xfrm>
-          <a:prstGeom prst="rect">
-            <a:avLst/>
-          </a:prstGeom>
-          <a:noFill/>
-          <a:ln/>
-        </p:spPr>
-        <p:txBody>
-          <a:bodyPr wrap="square" lIns="0" tIns="0" rIns="0" bIns="0" rtlCol="0" anchor="ctr"/>
+            <a:off x="548640" y="2697480"/>
+            <a:ext cx="7589520" cy="886460"/>
+          </a:xfrm>
+          <a:prstGeom prst="rect">
+            <a:avLst/>
+          </a:prstGeom>
+          <a:noFill/>
+          <a:ln/>
+        </p:spPr>
+        <p:txBody>
+          <a:bodyPr wrap="square" lIns="0" tIns="0" rIns="0" bIns="0" rtlCol="0" anchor="t"/>
           <a:lstStyle/>
           <a:p>
             <a:pPr indent="0" marL="0">
@@ -1321,9 +1347,9 @@
                 <a:solidFill>
                   <a:srgbClr val="FFFFFF"/>
                 </a:solidFill>
-                <a:latin typeface="Arial" pitchFamily="34" charset="0"/>
-                <a:ea typeface="Arial" pitchFamily="34" charset="-122"/>
-                <a:cs typeface="Arial" pitchFamily="34" charset="-120"/>
+                <a:latin typeface="Helvetica" pitchFamily="34" charset="0"/>
+                <a:ea typeface="Helvetica" pitchFamily="34" charset="-122"/>
+                <a:cs typeface="Helvetica" pitchFamily="34" charset="-120"/>
               </a:rPr>
               <a:t>Gmail + Claude</a:t>
             </a:r>
@@ -1339,20 +1365,23 @@
         </p:nvSpPr>
         <p:spPr>
           <a:xfrm>
-            <a:off x="502920" y="3840480"/>
-            <a:ext cx="7315200" cy="548640"/>
-          </a:xfrm>
-          <a:prstGeom prst="rect">
-            <a:avLst/>
-          </a:prstGeom>
-          <a:noFill/>
-          <a:ln/>
-        </p:spPr>
-        <p:txBody>
-          <a:bodyPr wrap="square" lIns="0" tIns="0" rIns="0" bIns="0" rtlCol="0" anchor="ctr"/>
-          <a:lstStyle/>
-          <a:p>
-            <a:pPr indent="0" marL="0">
+            <a:off x="548640" y="3721100"/>
+            <a:ext cx="7315200" cy="822960"/>
+          </a:xfrm>
+          <a:prstGeom prst="rect">
+            <a:avLst/>
+          </a:prstGeom>
+          <a:noFill/>
+          <a:ln/>
+        </p:spPr>
+        <p:txBody>
+          <a:bodyPr wrap="square" lIns="0" tIns="0" rIns="0" bIns="0" rtlCol="0" anchor="t"/>
+          <a:lstStyle/>
+          <a:p>
+            <a:pPr indent="0" marL="0">
+              <a:lnSpc>
+                <a:spcPct val="130000"/>
+              </a:lnSpc>
               <a:buNone/>
             </a:pPr>
             <a:r>
@@ -1360,52 +1389,13 @@
                 <a:solidFill>
                   <a:srgbClr val="B7C0D8"/>
                 </a:solidFill>
-                <a:latin typeface="Arial" pitchFamily="34" charset="0"/>
-                <a:ea typeface="Arial" pitchFamily="34" charset="-122"/>
-                <a:cs typeface="Arial" pitchFamily="34" charset="-120"/>
-              </a:rPr>
-              <a:t>Inbox bersih, email cepat</a:t>
+                <a:latin typeface="Helvetica" pitchFamily="34" charset="0"/>
+                <a:ea typeface="Helvetica" pitchFamily="34" charset="-122"/>
+                <a:cs typeface="Helvetica" pitchFamily="34" charset="-120"/>
+              </a:rPr>
+              <a:t>Inbox bersih, email cepat.</a:t>
             </a:r>
             <a:endParaRPr lang="en-US" sz="1550" dirty="0"/>
-          </a:p>
-        </p:txBody>
-      </p:sp>
-      <p:sp>
-        <p:nvSpPr>
-          <p:cNvPr id="9" name="Text 7"/>
-          <p:cNvSpPr/>
-          <p:nvPr/>
-        </p:nvSpPr>
-        <p:spPr>
-          <a:xfrm>
-            <a:off x="502920" y="4572000"/>
-            <a:ext cx="7315200" cy="365760"/>
-          </a:xfrm>
-          <a:prstGeom prst="rect">
-            <a:avLst/>
-          </a:prstGeom>
-          <a:noFill/>
-          <a:ln/>
-        </p:spPr>
-        <p:txBody>
-          <a:bodyPr wrap="square" lIns="0" tIns="0" rIns="0" bIns="0" rtlCol="0" anchor="ctr"/>
-          <a:lstStyle/>
-          <a:p>
-            <a:pPr indent="0" marL="0">
-              <a:buNone/>
-            </a:pPr>
-            <a:r>
-              <a:rPr lang="en-US" sz="1200" dirty="0">
-                <a:solidFill>
-                  <a:srgbClr val="9AA2B4"/>
-                </a:solidFill>
-                <a:latin typeface="Arial" pitchFamily="34" charset="0"/>
-                <a:ea typeface="Arial" pitchFamily="34" charset="-122"/>
-                <a:cs typeface="Arial" pitchFamily="34" charset="-120"/>
-              </a:rPr>
-              <a:t>Produktivitas Kantor</a:t>
-            </a:r>
-            <a:endParaRPr lang="en-US" sz="1200" dirty="0"/>
           </a:p>
         </p:txBody>
       </p:sp>
@@ -1420,6 +1410,13 @@
 <file path=ppt/slides/slide2.xml><?xml version="1.0" encoding="utf-8"?>
 <p:sld xmlns:a="http://schemas.openxmlformats.org/drawingml/2006/main" xmlns:r="http://schemas.openxmlformats.org/officeDocument/2006/relationships" xmlns:p="http://schemas.openxmlformats.org/presentationml/2006/main">
   <p:cSld name="Slide 2">
+    <p:bg>
+      <p:bgPr>
+        <a:solidFill>
+          <a:srgbClr val="FFFFFF"/>
+        </a:solidFill>
+      </p:bgPr>
+    </p:bg>
     <p:spTree>
       <p:nvGrpSpPr>
         <p:cNvPr id="1" name=""/>
@@ -1503,9 +1500,9 @@
                 <a:solidFill>
                   <a:srgbClr val="FFFFFF"/>
                 </a:solidFill>
-                <a:latin typeface="Arial" pitchFamily="34" charset="0"/>
-                <a:ea typeface="Arial" pitchFamily="34" charset="-122"/>
-                <a:cs typeface="Arial" pitchFamily="34" charset="-120"/>
+                <a:latin typeface="Helvetica" pitchFamily="34" charset="0"/>
+                <a:ea typeface="Helvetica" pitchFamily="34" charset="-122"/>
+                <a:cs typeface="Helvetica" pitchFamily="34" charset="-120"/>
               </a:rPr>
               <a:t>belajar</a:t>
             </a:r>
@@ -1517,9 +1514,9 @@
                 <a:solidFill>
                   <a:srgbClr val="8B7CF6"/>
                 </a:solidFill>
-                <a:latin typeface="Arial" pitchFamily="34" charset="0"/>
-                <a:ea typeface="Arial" pitchFamily="34" charset="-122"/>
-                <a:cs typeface="Arial" pitchFamily="34" charset="-120"/>
+                <a:latin typeface="Helvetica" pitchFamily="34" charset="0"/>
+                <a:ea typeface="Helvetica" pitchFamily="34" charset="-122"/>
+                <a:cs typeface="Helvetica" pitchFamily="34" charset="-120"/>
               </a:rPr>
               <a:t>claude</a:t>
             </a:r>
@@ -1556,9 +1553,9 @@
                 <a:solidFill>
                   <a:srgbClr val="9AA2B4"/>
                 </a:solidFill>
-                <a:latin typeface="Arial" pitchFamily="34" charset="0"/>
-                <a:ea typeface="Arial" pitchFamily="34" charset="-122"/>
-                <a:cs typeface="Arial" pitchFamily="34" charset="-120"/>
+                <a:latin typeface="Helvetica" pitchFamily="34" charset="0"/>
+                <a:ea typeface="Helvetica" pitchFamily="34" charset="-122"/>
+                <a:cs typeface="Helvetica" pitchFamily="34" charset="-120"/>
               </a:rPr>
               <a:t>Modul 03 — Gmail + Claude</a:t>
             </a:r>
@@ -1574,8 +1571,8 @@
         </p:nvSpPr>
         <p:spPr>
           <a:xfrm>
-            <a:off x="502920" y="1097280"/>
-            <a:ext cx="11155680" cy="548640"/>
+            <a:off x="548640" y="1188720"/>
+            <a:ext cx="11064240" cy="502920"/>
           </a:xfrm>
           <a:prstGeom prst="rect">
             <a:avLst/>
@@ -1595,9 +1592,9 @@
                 <a:solidFill>
                   <a:srgbClr val="0D1321"/>
                 </a:solidFill>
-                <a:latin typeface="Arial" pitchFamily="34" charset="0"/>
-                <a:ea typeface="Arial" pitchFamily="34" charset="-122"/>
-                <a:cs typeface="Arial" pitchFamily="34" charset="-120"/>
+                <a:latin typeface="Helvetica" pitchFamily="34" charset="0"/>
+                <a:ea typeface="Helvetica" pitchFamily="34" charset="-122"/>
+                <a:cs typeface="Helvetica" pitchFamily="34" charset="-120"/>
               </a:rPr>
               <a:t>Workflow Email dengan Claude</a:t>
             </a:r>
@@ -1613,8 +1610,8 @@
         </p:nvSpPr>
         <p:spPr>
           <a:xfrm>
-            <a:off x="502920" y="1737360"/>
-            <a:ext cx="11155680" cy="256032"/>
+            <a:off x="548640" y="1783080"/>
+            <a:ext cx="11094415" cy="274320"/>
           </a:xfrm>
           <a:prstGeom prst="rect">
             <a:avLst/>
@@ -1630,17 +1627,17 @@
               <a:buNone/>
             </a:pPr>
             <a:r>
-              <a:rPr lang="en-US" sz="1200" b="1" spc="30" kern="0" dirty="0">
+              <a:rPr lang="en-US" sz="1250" b="1" spc="40" kern="0" dirty="0">
                 <a:solidFill>
                   <a:srgbClr val="4B36C7"/>
                 </a:solidFill>
-                <a:latin typeface="Arial" pitchFamily="34" charset="0"/>
-                <a:ea typeface="Arial" pitchFamily="34" charset="-122"/>
-                <a:cs typeface="Arial" pitchFamily="34" charset="-120"/>
+                <a:latin typeface="Helvetica" pitchFamily="34" charset="0"/>
+                <a:ea typeface="Helvetica" pitchFamily="34" charset="-122"/>
+                <a:cs typeface="Helvetica" pitchFamily="34" charset="-120"/>
               </a:rPr>
               <a:t>4 LANGKAH DARI INBOX KE TERKIRIM</a:t>
             </a:r>
-            <a:endParaRPr lang="en-US" sz="1200" dirty="0"/>
+            <a:endParaRPr lang="en-US" sz="1250" dirty="0"/>
           </a:p>
         </p:txBody>
       </p:sp>
@@ -1652,12 +1649,12 @@
         </p:nvSpPr>
         <p:spPr>
           <a:xfrm>
-            <a:off x="502920" y="2084832"/>
-            <a:ext cx="2633472" cy="2011680"/>
+            <a:off x="548640" y="2112264"/>
+            <a:ext cx="2581580" cy="1700540"/>
           </a:xfrm>
           <a:prstGeom prst="roundRect">
             <a:avLst>
-              <a:gd name="adj" fmla="val 5455"/>
+              <a:gd name="adj" fmla="val 5377"/>
             </a:avLst>
           </a:prstGeom>
           <a:solidFill>
@@ -1679,8 +1676,8 @@
         </p:nvSpPr>
         <p:spPr>
           <a:xfrm>
-            <a:off x="685800" y="2249424"/>
-            <a:ext cx="402336" cy="402336"/>
+            <a:off x="749808" y="2313432"/>
+            <a:ext cx="384048" cy="384048"/>
           </a:xfrm>
           <a:prstGeom prst="ellipse">
             <a:avLst/>
@@ -1699,8 +1696,8 @@
         </p:nvSpPr>
         <p:spPr>
           <a:xfrm>
-            <a:off x="685800" y="2249424"/>
-            <a:ext cx="402336" cy="402336"/>
+            <a:off x="749808" y="2313432"/>
+            <a:ext cx="384048" cy="384048"/>
           </a:xfrm>
           <a:prstGeom prst="rect">
             <a:avLst/>
@@ -1716,17 +1713,17 @@
               <a:buNone/>
             </a:pPr>
             <a:r>
-              <a:rPr lang="en-US" sz="1600" b="1" dirty="0">
+              <a:rPr lang="en-US" sz="1400" b="1" dirty="0">
                 <a:solidFill>
                   <a:srgbClr val="FFFFFF"/>
                 </a:solidFill>
-                <a:latin typeface="Arial" pitchFamily="34" charset="0"/>
-                <a:ea typeface="Arial" pitchFamily="34" charset="-122"/>
-                <a:cs typeface="Arial" pitchFamily="34" charset="-120"/>
+                <a:latin typeface="Helvetica" pitchFamily="34" charset="0"/>
+                <a:ea typeface="Helvetica" pitchFamily="34" charset="-122"/>
+                <a:cs typeface="Helvetica" pitchFamily="34" charset="-120"/>
               </a:rPr>
               <a:t>1</a:t>
             </a:r>
-            <a:endParaRPr lang="en-US" sz="1600" dirty="0"/>
+            <a:endParaRPr lang="en-US" sz="1400" dirty="0"/>
           </a:p>
         </p:txBody>
       </p:sp>
@@ -1738,8 +1735,8 @@
         </p:nvSpPr>
         <p:spPr>
           <a:xfrm>
-            <a:off x="1216152" y="2267712"/>
-            <a:ext cx="1810512" cy="347472"/>
+            <a:off x="1271016" y="2295144"/>
+            <a:ext cx="1658036" cy="310896"/>
           </a:xfrm>
           <a:prstGeom prst="rect">
             <a:avLst/>
@@ -1755,17 +1752,17 @@
               <a:buNone/>
             </a:pPr>
             <a:r>
-              <a:rPr lang="en-US" sz="1300" b="1" dirty="0">
-                <a:solidFill>
-                  <a:srgbClr val="4B36C7"/>
-                </a:solidFill>
-                <a:latin typeface="Arial" pitchFamily="34" charset="0"/>
-                <a:ea typeface="Arial" pitchFamily="34" charset="-122"/>
-                <a:cs typeface="Arial" pitchFamily="34" charset="-120"/>
+              <a:rPr lang="en-US" sz="1400" b="1" dirty="0">
+                <a:solidFill>
+                  <a:srgbClr val="0D1321"/>
+                </a:solidFill>
+                <a:latin typeface="Helvetica" pitchFamily="34" charset="0"/>
+                <a:ea typeface="Helvetica" pitchFamily="34" charset="-122"/>
+                <a:cs typeface="Helvetica" pitchFamily="34" charset="-120"/>
               </a:rPr>
               <a:t>Baca Email</a:t>
             </a:r>
-            <a:endParaRPr lang="en-US" sz="1300" dirty="0"/>
+            <a:endParaRPr lang="en-US" sz="1400" dirty="0"/>
           </a:p>
         </p:txBody>
       </p:sp>
@@ -1777,8 +1774,8 @@
         </p:nvSpPr>
         <p:spPr>
           <a:xfrm>
-            <a:off x="640080" y="2724912"/>
-            <a:ext cx="2359152" cy="1234440"/>
+            <a:off x="749808" y="2734056"/>
+            <a:ext cx="2179244" cy="877580"/>
           </a:xfrm>
           <a:prstGeom prst="rect">
             <a:avLst/>
@@ -1792,7 +1789,7 @@
           <a:p>
             <a:pPr indent="0" marL="0">
               <a:lnSpc>
-                <a:spcPct val="125000"/>
+                <a:spcPct val="122000"/>
               </a:lnSpc>
               <a:buNone/>
             </a:pPr>
@@ -1801,9 +1798,9 @@
                 <a:solidFill>
                   <a:srgbClr val="23283A"/>
                 </a:solidFill>
-                <a:latin typeface="Arial" pitchFamily="34" charset="0"/>
-                <a:ea typeface="Arial" pitchFamily="34" charset="-122"/>
-                <a:cs typeface="Arial" pitchFamily="34" charset="-120"/>
+                <a:latin typeface="Helvetica" pitchFamily="34" charset="0"/>
+                <a:ea typeface="Helvetica" pitchFamily="34" charset="-122"/>
+                <a:cs typeface="Helvetica" pitchFamily="34" charset="-120"/>
               </a:rPr>
               <a:t>Buka email masuk. Pahami inti pesan: apa yang diminta, siapa pengirimnya, seberapa urgent.</a:t>
             </a:r>
@@ -1819,12 +1816,12 @@
         </p:nvSpPr>
         <p:spPr>
           <a:xfrm>
-            <a:off x="3287268" y="2084832"/>
-            <a:ext cx="2633472" cy="2011680"/>
+            <a:off x="3386252" y="2112264"/>
+            <a:ext cx="2581580" cy="1700540"/>
           </a:xfrm>
           <a:prstGeom prst="roundRect">
             <a:avLst>
-              <a:gd name="adj" fmla="val 5455"/>
+              <a:gd name="adj" fmla="val 5377"/>
             </a:avLst>
           </a:prstGeom>
           <a:solidFill>
@@ -1846,8 +1843,8 @@
         </p:nvSpPr>
         <p:spPr>
           <a:xfrm>
-            <a:off x="3470148" y="2249424"/>
-            <a:ext cx="402336" cy="402336"/>
+            <a:off x="3587420" y="2313432"/>
+            <a:ext cx="384048" cy="384048"/>
           </a:xfrm>
           <a:prstGeom prst="ellipse">
             <a:avLst/>
@@ -1866,8 +1863,8 @@
         </p:nvSpPr>
         <p:spPr>
           <a:xfrm>
-            <a:off x="3470148" y="2249424"/>
-            <a:ext cx="402336" cy="402336"/>
+            <a:off x="3587420" y="2313432"/>
+            <a:ext cx="384048" cy="384048"/>
           </a:xfrm>
           <a:prstGeom prst="rect">
             <a:avLst/>
@@ -1883,17 +1880,17 @@
               <a:buNone/>
             </a:pPr>
             <a:r>
-              <a:rPr lang="en-US" sz="1600" b="1" dirty="0">
+              <a:rPr lang="en-US" sz="1400" b="1" dirty="0">
                 <a:solidFill>
                   <a:srgbClr val="FFFFFF"/>
                 </a:solidFill>
-                <a:latin typeface="Arial" pitchFamily="34" charset="0"/>
-                <a:ea typeface="Arial" pitchFamily="34" charset="-122"/>
-                <a:cs typeface="Arial" pitchFamily="34" charset="-120"/>
+                <a:latin typeface="Helvetica" pitchFamily="34" charset="0"/>
+                <a:ea typeface="Helvetica" pitchFamily="34" charset="-122"/>
+                <a:cs typeface="Helvetica" pitchFamily="34" charset="-120"/>
               </a:rPr>
               <a:t>2</a:t>
             </a:r>
-            <a:endParaRPr lang="en-US" sz="1600" dirty="0"/>
+            <a:endParaRPr lang="en-US" sz="1400" dirty="0"/>
           </a:p>
         </p:txBody>
       </p:sp>
@@ -1905,8 +1902,8 @@
         </p:nvSpPr>
         <p:spPr>
           <a:xfrm>
-            <a:off x="4000500" y="2267712"/>
-            <a:ext cx="1810512" cy="347472"/>
+            <a:off x="4108628" y="2295144"/>
+            <a:ext cx="1658036" cy="310896"/>
           </a:xfrm>
           <a:prstGeom prst="rect">
             <a:avLst/>
@@ -1922,17 +1919,17 @@
               <a:buNone/>
             </a:pPr>
             <a:r>
-              <a:rPr lang="en-US" sz="1300" b="1" dirty="0">
-                <a:solidFill>
-                  <a:srgbClr val="4B36C7"/>
-                </a:solidFill>
-                <a:latin typeface="Arial" pitchFamily="34" charset="0"/>
-                <a:ea typeface="Arial" pitchFamily="34" charset="-122"/>
-                <a:cs typeface="Arial" pitchFamily="34" charset="-120"/>
+              <a:rPr lang="en-US" sz="1400" b="1" dirty="0">
+                <a:solidFill>
+                  <a:srgbClr val="0D1321"/>
+                </a:solidFill>
+                <a:latin typeface="Helvetica" pitchFamily="34" charset="0"/>
+                <a:ea typeface="Helvetica" pitchFamily="34" charset="-122"/>
+                <a:cs typeface="Helvetica" pitchFamily="34" charset="-120"/>
               </a:rPr>
               <a:t>Tulis Prompt</a:t>
             </a:r>
-            <a:endParaRPr lang="en-US" sz="1300" dirty="0"/>
+            <a:endParaRPr lang="en-US" sz="1400" dirty="0"/>
           </a:p>
         </p:txBody>
       </p:sp>
@@ -1944,8 +1941,8 @@
         </p:nvSpPr>
         <p:spPr>
           <a:xfrm>
-            <a:off x="3424428" y="2724912"/>
-            <a:ext cx="2359152" cy="1234440"/>
+            <a:off x="3587420" y="2734056"/>
+            <a:ext cx="2179244" cy="877580"/>
           </a:xfrm>
           <a:prstGeom prst="rect">
             <a:avLst/>
@@ -1959,7 +1956,7 @@
           <a:p>
             <a:pPr indent="0" marL="0">
               <a:lnSpc>
-                <a:spcPct val="125000"/>
+                <a:spcPct val="122000"/>
               </a:lnSpc>
               <a:buNone/>
             </a:pPr>
@@ -1968,11 +1965,11 @@
                 <a:solidFill>
                   <a:srgbClr val="23283A"/>
                 </a:solidFill>
-                <a:latin typeface="Arial" pitchFamily="34" charset="0"/>
-                <a:ea typeface="Arial" pitchFamily="34" charset="-122"/>
-                <a:cs typeface="Arial" pitchFamily="34" charset="-120"/>
-              </a:rPr>
-              <a:t>Ceritakan konteks ke Claude: "email dari siapa, isinya apa, tone yang diinginkan". Pakai 3 Elemen Wajib.</a:t>
+                <a:latin typeface="Helvetica" pitchFamily="34" charset="0"/>
+                <a:ea typeface="Helvetica" pitchFamily="34" charset="-122"/>
+                <a:cs typeface="Helvetica" pitchFamily="34" charset="-120"/>
+              </a:rPr>
+              <a:t>Ceritakan konteks ke Claude: email dari siapa, isinya apa, tone yang diinginkan. Pakai 3 Elemen Wajib.</a:t>
             </a:r>
             <a:endParaRPr lang="en-US" sz="1200" dirty="0"/>
           </a:p>
@@ -1986,12 +1983,12 @@
         </p:nvSpPr>
         <p:spPr>
           <a:xfrm>
-            <a:off x="6071616" y="2084832"/>
-            <a:ext cx="2633472" cy="2011680"/>
+            <a:off x="6223864" y="2112264"/>
+            <a:ext cx="2581580" cy="1700540"/>
           </a:xfrm>
           <a:prstGeom prst="roundRect">
             <a:avLst>
-              <a:gd name="adj" fmla="val 5455"/>
+              <a:gd name="adj" fmla="val 5377"/>
             </a:avLst>
           </a:prstGeom>
           <a:solidFill>
@@ -2013,8 +2010,8 @@
         </p:nvSpPr>
         <p:spPr>
           <a:xfrm>
-            <a:off x="6254496" y="2249424"/>
-            <a:ext cx="402336" cy="402336"/>
+            <a:off x="6425032" y="2313432"/>
+            <a:ext cx="384048" cy="384048"/>
           </a:xfrm>
           <a:prstGeom prst="ellipse">
             <a:avLst/>
@@ -2033,8 +2030,8 @@
         </p:nvSpPr>
         <p:spPr>
           <a:xfrm>
-            <a:off x="6254496" y="2249424"/>
-            <a:ext cx="402336" cy="402336"/>
+            <a:off x="6425032" y="2313432"/>
+            <a:ext cx="384048" cy="384048"/>
           </a:xfrm>
           <a:prstGeom prst="rect">
             <a:avLst/>
@@ -2050,17 +2047,17 @@
               <a:buNone/>
             </a:pPr>
             <a:r>
-              <a:rPr lang="en-US" sz="1600" b="1" dirty="0">
+              <a:rPr lang="en-US" sz="1400" b="1" dirty="0">
                 <a:solidFill>
                   <a:srgbClr val="FFFFFF"/>
                 </a:solidFill>
-                <a:latin typeface="Arial" pitchFamily="34" charset="0"/>
-                <a:ea typeface="Arial" pitchFamily="34" charset="-122"/>
-                <a:cs typeface="Arial" pitchFamily="34" charset="-120"/>
+                <a:latin typeface="Helvetica" pitchFamily="34" charset="0"/>
+                <a:ea typeface="Helvetica" pitchFamily="34" charset="-122"/>
+                <a:cs typeface="Helvetica" pitchFamily="34" charset="-120"/>
               </a:rPr>
               <a:t>3</a:t>
             </a:r>
-            <a:endParaRPr lang="en-US" sz="1600" dirty="0"/>
+            <a:endParaRPr lang="en-US" sz="1400" dirty="0"/>
           </a:p>
         </p:txBody>
       </p:sp>
@@ -2072,8 +2069,8 @@
         </p:nvSpPr>
         <p:spPr>
           <a:xfrm>
-            <a:off x="6784848" y="2267712"/>
-            <a:ext cx="1810512" cy="347472"/>
+            <a:off x="6946240" y="2295144"/>
+            <a:ext cx="1658036" cy="310896"/>
           </a:xfrm>
           <a:prstGeom prst="rect">
             <a:avLst/>
@@ -2089,17 +2086,17 @@
               <a:buNone/>
             </a:pPr>
             <a:r>
-              <a:rPr lang="en-US" sz="1300" b="1" dirty="0">
-                <a:solidFill>
-                  <a:srgbClr val="4B36C7"/>
-                </a:solidFill>
-                <a:latin typeface="Arial" pitchFamily="34" charset="0"/>
-                <a:ea typeface="Arial" pitchFamily="34" charset="-122"/>
-                <a:cs typeface="Arial" pitchFamily="34" charset="-120"/>
+              <a:rPr lang="en-US" sz="1400" b="1" dirty="0">
+                <a:solidFill>
+                  <a:srgbClr val="0D1321"/>
+                </a:solidFill>
+                <a:latin typeface="Helvetica" pitchFamily="34" charset="0"/>
+                <a:ea typeface="Helvetica" pitchFamily="34" charset="-122"/>
+                <a:cs typeface="Helvetica" pitchFamily="34" charset="-120"/>
               </a:rPr>
               <a:t>Baca &amp; Edit</a:t>
             </a:r>
-            <a:endParaRPr lang="en-US" sz="1300" dirty="0"/>
+            <a:endParaRPr lang="en-US" sz="1400" dirty="0"/>
           </a:p>
         </p:txBody>
       </p:sp>
@@ -2111,8 +2108,8 @@
         </p:nvSpPr>
         <p:spPr>
           <a:xfrm>
-            <a:off x="6208776" y="2724912"/>
-            <a:ext cx="2359152" cy="1234440"/>
+            <a:off x="6425032" y="2734056"/>
+            <a:ext cx="2179244" cy="877580"/>
           </a:xfrm>
           <a:prstGeom prst="rect">
             <a:avLst/>
@@ -2126,7 +2123,7 @@
           <a:p>
             <a:pPr indent="0" marL="0">
               <a:lnSpc>
-                <a:spcPct val="125000"/>
+                <a:spcPct val="122000"/>
               </a:lnSpc>
               <a:buNone/>
             </a:pPr>
@@ -2135,9 +2132,9 @@
                 <a:solidFill>
                   <a:srgbClr val="23283A"/>
                 </a:solidFill>
-                <a:latin typeface="Arial" pitchFamily="34" charset="0"/>
-                <a:ea typeface="Arial" pitchFamily="34" charset="-122"/>
-                <a:cs typeface="Arial" pitchFamily="34" charset="-120"/>
+                <a:latin typeface="Helvetica" pitchFamily="34" charset="0"/>
+                <a:ea typeface="Helvetica" pitchFamily="34" charset="-122"/>
+                <a:cs typeface="Helvetica" pitchFamily="34" charset="-120"/>
               </a:rPr>
               <a:t>Baca output Claude. Tambahkan info personal atau detail spesifik yang hanya kamu tahu. Sesuaikan jika perlu.</a:t>
             </a:r>
@@ -2153,12 +2150,12 @@
         </p:nvSpPr>
         <p:spPr>
           <a:xfrm>
-            <a:off x="8855964" y="2084832"/>
-            <a:ext cx="2633472" cy="2011680"/>
+            <a:off x="9061475" y="2112264"/>
+            <a:ext cx="2581580" cy="1700540"/>
           </a:xfrm>
           <a:prstGeom prst="roundRect">
             <a:avLst>
-              <a:gd name="adj" fmla="val 5455"/>
+              <a:gd name="adj" fmla="val 5377"/>
             </a:avLst>
           </a:prstGeom>
           <a:solidFill>
@@ -2180,8 +2177,8 @@
         </p:nvSpPr>
         <p:spPr>
           <a:xfrm>
-            <a:off x="9038844" y="2249424"/>
-            <a:ext cx="402336" cy="402336"/>
+            <a:off x="9262643" y="2313432"/>
+            <a:ext cx="384048" cy="384048"/>
           </a:xfrm>
           <a:prstGeom prst="ellipse">
             <a:avLst/>
@@ -2200,8 +2197,8 @@
         </p:nvSpPr>
         <p:spPr>
           <a:xfrm>
-            <a:off x="9038844" y="2249424"/>
-            <a:ext cx="402336" cy="402336"/>
+            <a:off x="9262643" y="2313432"/>
+            <a:ext cx="384048" cy="384048"/>
           </a:xfrm>
           <a:prstGeom prst="rect">
             <a:avLst/>
@@ -2217,17 +2214,17 @@
               <a:buNone/>
             </a:pPr>
             <a:r>
-              <a:rPr lang="en-US" sz="1600" b="1" dirty="0">
+              <a:rPr lang="en-US" sz="1400" b="1" dirty="0">
                 <a:solidFill>
                   <a:srgbClr val="FFFFFF"/>
                 </a:solidFill>
-                <a:latin typeface="Arial" pitchFamily="34" charset="0"/>
-                <a:ea typeface="Arial" pitchFamily="34" charset="-122"/>
-                <a:cs typeface="Arial" pitchFamily="34" charset="-120"/>
+                <a:latin typeface="Helvetica" pitchFamily="34" charset="0"/>
+                <a:ea typeface="Helvetica" pitchFamily="34" charset="-122"/>
+                <a:cs typeface="Helvetica" pitchFamily="34" charset="-120"/>
               </a:rPr>
               <a:t>4</a:t>
             </a:r>
-            <a:endParaRPr lang="en-US" sz="1600" dirty="0"/>
+            <a:endParaRPr lang="en-US" sz="1400" dirty="0"/>
           </a:p>
         </p:txBody>
       </p:sp>
@@ -2239,8 +2236,8 @@
         </p:nvSpPr>
         <p:spPr>
           <a:xfrm>
-            <a:off x="9569196" y="2267712"/>
-            <a:ext cx="1810512" cy="347472"/>
+            <a:off x="9783851" y="2295144"/>
+            <a:ext cx="1658036" cy="310896"/>
           </a:xfrm>
           <a:prstGeom prst="rect">
             <a:avLst/>
@@ -2256,98 +2253,98 @@
               <a:buNone/>
             </a:pPr>
             <a:r>
-              <a:rPr lang="en-US" sz="1300" b="1" dirty="0">
+              <a:rPr lang="en-US" sz="1400" b="1" dirty="0">
+                <a:solidFill>
+                  <a:srgbClr val="0D1321"/>
+                </a:solidFill>
+                <a:latin typeface="Helvetica" pitchFamily="34" charset="0"/>
+                <a:ea typeface="Helvetica" pitchFamily="34" charset="-122"/>
+                <a:cs typeface="Helvetica" pitchFamily="34" charset="-120"/>
+              </a:rPr>
+              <a:t>Kirim</a:t>
+            </a:r>
+            <a:endParaRPr lang="en-US" sz="1400" dirty="0"/>
+          </a:p>
+        </p:txBody>
+      </p:sp>
+      <p:sp>
+        <p:nvSpPr>
+          <p:cNvPr id="27" name="Text 25"/>
+          <p:cNvSpPr/>
+          <p:nvPr/>
+        </p:nvSpPr>
+        <p:spPr>
+          <a:xfrm>
+            <a:off x="9262643" y="2734056"/>
+            <a:ext cx="2179244" cy="877580"/>
+          </a:xfrm>
+          <a:prstGeom prst="rect">
+            <a:avLst/>
+          </a:prstGeom>
+          <a:noFill/>
+          <a:ln/>
+        </p:spPr>
+        <p:txBody>
+          <a:bodyPr wrap="square" lIns="0" tIns="0" rIns="0" bIns="0" rtlCol="0" anchor="t"/>
+          <a:lstStyle/>
+          <a:p>
+            <a:pPr indent="0" marL="0">
+              <a:lnSpc>
+                <a:spcPct val="122000"/>
+              </a:lnSpc>
+              <a:buNone/>
+            </a:pPr>
+            <a:r>
+              <a:rPr lang="en-US" sz="1200" dirty="0">
+                <a:solidFill>
+                  <a:srgbClr val="23283A"/>
+                </a:solidFill>
+                <a:latin typeface="Helvetica" pitchFamily="34" charset="0"/>
+                <a:ea typeface="Helvetica" pitchFamily="34" charset="-122"/>
+                <a:cs typeface="Helvetica" pitchFamily="34" charset="-120"/>
+              </a:rPr>
+              <a:t>Lakukan checklist sebelum kirim. Pastikan nama, detail, dan tone sudah sesuai. Baru tekan "Send".</a:t>
+            </a:r>
+            <a:endParaRPr lang="en-US" sz="1200" dirty="0"/>
+          </a:p>
+        </p:txBody>
+      </p:sp>
+      <p:sp>
+        <p:nvSpPr>
+          <p:cNvPr id="28" name="Text 26"/>
+          <p:cNvSpPr/>
+          <p:nvPr/>
+        </p:nvSpPr>
+        <p:spPr>
+          <a:xfrm>
+            <a:off x="548640" y="4050548"/>
+            <a:ext cx="11094415" cy="274320"/>
+          </a:xfrm>
+          <a:prstGeom prst="rect">
+            <a:avLst/>
+          </a:prstGeom>
+          <a:noFill/>
+          <a:ln/>
+        </p:spPr>
+        <p:txBody>
+          <a:bodyPr wrap="square" lIns="0" tIns="0" rIns="0" bIns="0" rtlCol="0" anchor="ctr"/>
+          <a:lstStyle/>
+          <a:p>
+            <a:pPr indent="0" marL="0">
+              <a:buNone/>
+            </a:pPr>
+            <a:r>
+              <a:rPr lang="en-US" sz="1250" b="1" spc="40" kern="0" dirty="0">
                 <a:solidFill>
                   <a:srgbClr val="4B36C7"/>
                 </a:solidFill>
-                <a:latin typeface="Arial" pitchFamily="34" charset="0"/>
-                <a:ea typeface="Arial" pitchFamily="34" charset="-122"/>
-                <a:cs typeface="Arial" pitchFamily="34" charset="-120"/>
-              </a:rPr>
-              <a:t>Kirim</a:t>
-            </a:r>
-            <a:endParaRPr lang="en-US" sz="1300" dirty="0"/>
-          </a:p>
-        </p:txBody>
-      </p:sp>
-      <p:sp>
-        <p:nvSpPr>
-          <p:cNvPr id="27" name="Text 25"/>
-          <p:cNvSpPr/>
-          <p:nvPr/>
-        </p:nvSpPr>
-        <p:spPr>
-          <a:xfrm>
-            <a:off x="8993124" y="2724912"/>
-            <a:ext cx="2359152" cy="1234440"/>
-          </a:xfrm>
-          <a:prstGeom prst="rect">
-            <a:avLst/>
-          </a:prstGeom>
-          <a:noFill/>
-          <a:ln/>
-        </p:spPr>
-        <p:txBody>
-          <a:bodyPr wrap="square" lIns="0" tIns="0" rIns="0" bIns="0" rtlCol="0" anchor="t"/>
-          <a:lstStyle/>
-          <a:p>
-            <a:pPr indent="0" marL="0">
-              <a:lnSpc>
-                <a:spcPct val="125000"/>
-              </a:lnSpc>
-              <a:buNone/>
-            </a:pPr>
-            <a:r>
-              <a:rPr lang="en-US" sz="1200" dirty="0">
-                <a:solidFill>
-                  <a:srgbClr val="23283A"/>
-                </a:solidFill>
-                <a:latin typeface="Arial" pitchFamily="34" charset="0"/>
-                <a:ea typeface="Arial" pitchFamily="34" charset="-122"/>
-                <a:cs typeface="Arial" pitchFamily="34" charset="-120"/>
-              </a:rPr>
-              <a:t>Lakukan checklist sebelum kirim. Pastikan nama, detail, dan tone sudah sesuai. Baru tekan "Send".</a:t>
-            </a:r>
-            <a:endParaRPr lang="en-US" sz="1200" dirty="0"/>
-          </a:p>
-        </p:txBody>
-      </p:sp>
-      <p:sp>
-        <p:nvSpPr>
-          <p:cNvPr id="28" name="Text 26"/>
-          <p:cNvSpPr/>
-          <p:nvPr/>
-        </p:nvSpPr>
-        <p:spPr>
-          <a:xfrm>
-            <a:off x="502920" y="4352544"/>
-            <a:ext cx="11155680" cy="256032"/>
-          </a:xfrm>
-          <a:prstGeom prst="rect">
-            <a:avLst/>
-          </a:prstGeom>
-          <a:noFill/>
-          <a:ln/>
-        </p:spPr>
-        <p:txBody>
-          <a:bodyPr wrap="square" lIns="0" tIns="0" rIns="0" bIns="0" rtlCol="0" anchor="ctr"/>
-          <a:lstStyle/>
-          <a:p>
-            <a:pPr indent="0" marL="0">
-              <a:buNone/>
-            </a:pPr>
-            <a:r>
-              <a:rPr lang="en-US" sz="1200" b="1" spc="30" kern="0" dirty="0">
-                <a:solidFill>
-                  <a:srgbClr val="4B36C7"/>
-                </a:solidFill>
-                <a:latin typeface="Arial" pitchFamily="34" charset="0"/>
-                <a:ea typeface="Arial" pitchFamily="34" charset="-122"/>
-                <a:cs typeface="Arial" pitchFamily="34" charset="-120"/>
+                <a:latin typeface="Helvetica" pitchFamily="34" charset="0"/>
+                <a:ea typeface="Helvetica" pitchFamily="34" charset="-122"/>
+                <a:cs typeface="Helvetica" pitchFamily="34" charset="-120"/>
               </a:rPr>
               <a:t>3 ELEMEN WAJIB PROMPT EMAIL</a:t>
             </a:r>
-            <a:endParaRPr lang="en-US" sz="1200" dirty="0"/>
+            <a:endParaRPr lang="en-US" sz="1250" dirty="0"/>
           </a:p>
         </p:txBody>
       </p:sp>
@@ -2359,20 +2356,20 @@
         </p:nvSpPr>
         <p:spPr>
           <a:xfrm>
-            <a:off x="502920" y="4718304"/>
-            <a:ext cx="3547872" cy="1664208"/>
+            <a:off x="548640" y="4379732"/>
+            <a:ext cx="3527450" cy="1481145"/>
           </a:xfrm>
           <a:prstGeom prst="roundRect">
             <a:avLst>
-              <a:gd name="adj" fmla="val 5495"/>
+              <a:gd name="adj" fmla="val 6174"/>
             </a:avLst>
           </a:prstGeom>
           <a:solidFill>
-            <a:srgbClr val="FEE2E2"/>
+            <a:srgbClr val="F3F0FF"/>
           </a:solidFill>
           <a:ln w="12700">
             <a:solidFill>
-              <a:srgbClr val="D6DCEB"/>
+              <a:srgbClr val="DCD3FB"/>
             </a:solidFill>
             <a:prstDash val="solid"/>
           </a:ln>
@@ -2386,14 +2383,14 @@
         </p:nvSpPr>
         <p:spPr>
           <a:xfrm>
-            <a:off x="667512" y="4882896"/>
+            <a:off x="749808" y="4580900"/>
             <a:ext cx="384048" cy="384048"/>
           </a:xfrm>
           <a:prstGeom prst="ellipse">
             <a:avLst/>
           </a:prstGeom>
           <a:solidFill>
-            <a:srgbClr val="991B1B"/>
+            <a:srgbClr val="6849F6"/>
           </a:solidFill>
           <a:ln/>
         </p:spPr>
@@ -2406,7 +2403,7 @@
         </p:nvSpPr>
         <p:spPr>
           <a:xfrm>
-            <a:off x="667512" y="4882896"/>
+            <a:off x="749808" y="4580900"/>
             <a:ext cx="384048" cy="384048"/>
           </a:xfrm>
           <a:prstGeom prst="rect">
@@ -2427,9 +2424,9 @@
                 <a:solidFill>
                   <a:srgbClr val="FFFFFF"/>
                 </a:solidFill>
-                <a:latin typeface="Arial" pitchFamily="34" charset="0"/>
-                <a:ea typeface="Arial" pitchFamily="34" charset="-122"/>
-                <a:cs typeface="Arial" pitchFamily="34" charset="-120"/>
+                <a:latin typeface="Helvetica" pitchFamily="34" charset="0"/>
+                <a:ea typeface="Helvetica" pitchFamily="34" charset="-122"/>
+                <a:cs typeface="Helvetica" pitchFamily="34" charset="-120"/>
               </a:rPr>
               <a:t>A</a:t>
             </a:r>
@@ -2445,8 +2442,8 @@
         </p:nvSpPr>
         <p:spPr>
           <a:xfrm>
-            <a:off x="1161288" y="4901184"/>
-            <a:ext cx="2770632" cy="320040"/>
+            <a:off x="1271016" y="4562612"/>
+            <a:ext cx="2603906" cy="310896"/>
           </a:xfrm>
           <a:prstGeom prst="rect">
             <a:avLst/>
@@ -2462,17 +2459,17 @@
               <a:buNone/>
             </a:pPr>
             <a:r>
-              <a:rPr lang="en-US" sz="1250" b="1" dirty="0">
-                <a:solidFill>
-                  <a:srgbClr val="991B1B"/>
-                </a:solidFill>
-                <a:latin typeface="Arial" pitchFamily="34" charset="0"/>
-                <a:ea typeface="Arial" pitchFamily="34" charset="-122"/>
-                <a:cs typeface="Arial" pitchFamily="34" charset="-120"/>
+              <a:rPr lang="en-US" sz="1400" b="1" dirty="0">
+                <a:solidFill>
+                  <a:srgbClr val="0D1321"/>
+                </a:solidFill>
+                <a:latin typeface="Helvetica" pitchFamily="34" charset="0"/>
+                <a:ea typeface="Helvetica" pitchFamily="34" charset="-122"/>
+                <a:cs typeface="Helvetica" pitchFamily="34" charset="-120"/>
               </a:rPr>
               <a:t>Konteks Penerima</a:t>
             </a:r>
-            <a:endParaRPr lang="en-US" sz="1250" dirty="0"/>
+            <a:endParaRPr lang="en-US" sz="1400" dirty="0"/>
           </a:p>
         </p:txBody>
       </p:sp>
@@ -2484,8 +2481,8 @@
         </p:nvSpPr>
         <p:spPr>
           <a:xfrm>
-            <a:off x="667512" y="5312664"/>
-            <a:ext cx="3218688" cy="914400"/>
+            <a:off x="749808" y="5001524"/>
+            <a:ext cx="3125114" cy="658185"/>
           </a:xfrm>
           <a:prstGeom prst="rect">
             <a:avLst/>
@@ -2499,7 +2496,7 @@
           <a:p>
             <a:pPr indent="0" marL="0">
               <a:lnSpc>
-                <a:spcPct val="125000"/>
+                <a:spcPct val="122000"/>
               </a:lnSpc>
               <a:buNone/>
             </a:pPr>
@@ -2508,9 +2505,9 @@
                 <a:solidFill>
                   <a:srgbClr val="23283A"/>
                 </a:solidFill>
-                <a:latin typeface="Arial" pitchFamily="34" charset="0"/>
-                <a:ea typeface="Arial" pitchFamily="34" charset="-122"/>
-                <a:cs typeface="Arial" pitchFamily="34" charset="-120"/>
+                <a:latin typeface="Helvetica" pitchFamily="34" charset="0"/>
+                <a:ea typeface="Helvetica" pitchFamily="34" charset="-122"/>
+                <a:cs typeface="Helvetica" pitchFamily="34" charset="-120"/>
               </a:rPr>
               <a:t>Siapa yang menerima? Hubungan apa (klien baru, supplier lama, pelanggan kecewa)? Tingkat formalitas yang sesuai?</a:t>
             </a:r>
@@ -2526,12 +2523,12 @@
         </p:nvSpPr>
         <p:spPr>
           <a:xfrm>
-            <a:off x="4251960" y="4718304"/>
-            <a:ext cx="3547872" cy="1664208"/>
+            <a:off x="4332122" y="4379732"/>
+            <a:ext cx="3527450" cy="1481145"/>
           </a:xfrm>
           <a:prstGeom prst="roundRect">
             <a:avLst>
-              <a:gd name="adj" fmla="val 5495"/>
+              <a:gd name="adj" fmla="val 6174"/>
             </a:avLst>
           </a:prstGeom>
           <a:solidFill>
@@ -2539,7 +2536,7 @@
           </a:solidFill>
           <a:ln w="12700">
             <a:solidFill>
-              <a:srgbClr val="D6DCEB"/>
+              <a:srgbClr val="DCD3FB"/>
             </a:solidFill>
             <a:prstDash val="solid"/>
           </a:ln>
@@ -2553,14 +2550,14 @@
         </p:nvSpPr>
         <p:spPr>
           <a:xfrm>
-            <a:off x="4416552" y="4882896"/>
+            <a:off x="4533290" y="4580900"/>
             <a:ext cx="384048" cy="384048"/>
           </a:xfrm>
           <a:prstGeom prst="ellipse">
             <a:avLst/>
           </a:prstGeom>
           <a:solidFill>
-            <a:srgbClr val="4B36C7"/>
+            <a:srgbClr val="6849F6"/>
           </a:solidFill>
           <a:ln/>
         </p:spPr>
@@ -2573,7 +2570,7 @@
         </p:nvSpPr>
         <p:spPr>
           <a:xfrm>
-            <a:off x="4416552" y="4882896"/>
+            <a:off x="4533290" y="4580900"/>
             <a:ext cx="384048" cy="384048"/>
           </a:xfrm>
           <a:prstGeom prst="rect">
@@ -2594,9 +2591,9 @@
                 <a:solidFill>
                   <a:srgbClr val="FFFFFF"/>
                 </a:solidFill>
-                <a:latin typeface="Arial" pitchFamily="34" charset="0"/>
-                <a:ea typeface="Arial" pitchFamily="34" charset="-122"/>
-                <a:cs typeface="Arial" pitchFamily="34" charset="-120"/>
+                <a:latin typeface="Helvetica" pitchFamily="34" charset="0"/>
+                <a:ea typeface="Helvetica" pitchFamily="34" charset="-122"/>
+                <a:cs typeface="Helvetica" pitchFamily="34" charset="-120"/>
               </a:rPr>
               <a:t>B</a:t>
             </a:r>
@@ -2612,8 +2609,8 @@
         </p:nvSpPr>
         <p:spPr>
           <a:xfrm>
-            <a:off x="4910328" y="4901184"/>
-            <a:ext cx="2770632" cy="320040"/>
+            <a:off x="5054498" y="4562612"/>
+            <a:ext cx="2603906" cy="310896"/>
           </a:xfrm>
           <a:prstGeom prst="rect">
             <a:avLst/>
@@ -2629,17 +2626,17 @@
               <a:buNone/>
             </a:pPr>
             <a:r>
-              <a:rPr lang="en-US" sz="1250" b="1" dirty="0">
-                <a:solidFill>
-                  <a:srgbClr val="4B36C7"/>
-                </a:solidFill>
-                <a:latin typeface="Arial" pitchFamily="34" charset="0"/>
-                <a:ea typeface="Arial" pitchFamily="34" charset="-122"/>
-                <a:cs typeface="Arial" pitchFamily="34" charset="-120"/>
+              <a:rPr lang="en-US" sz="1400" b="1" dirty="0">
+                <a:solidFill>
+                  <a:srgbClr val="0D1321"/>
+                </a:solidFill>
+                <a:latin typeface="Helvetica" pitchFamily="34" charset="0"/>
+                <a:ea typeface="Helvetica" pitchFamily="34" charset="-122"/>
+                <a:cs typeface="Helvetica" pitchFamily="34" charset="-120"/>
               </a:rPr>
               <a:t>Inti Pesan</a:t>
             </a:r>
-            <a:endParaRPr lang="en-US" sz="1250" dirty="0"/>
+            <a:endParaRPr lang="en-US" sz="1400" dirty="0"/>
           </a:p>
         </p:txBody>
       </p:sp>
@@ -2651,8 +2648,8 @@
         </p:nvSpPr>
         <p:spPr>
           <a:xfrm>
-            <a:off x="4416552" y="5312664"/>
-            <a:ext cx="3218688" cy="914400"/>
+            <a:off x="4533290" y="5001524"/>
+            <a:ext cx="3125114" cy="658185"/>
           </a:xfrm>
           <a:prstGeom prst="rect">
             <a:avLst/>
@@ -2666,7 +2663,7 @@
           <a:p>
             <a:pPr indent="0" marL="0">
               <a:lnSpc>
-                <a:spcPct val="125000"/>
+                <a:spcPct val="122000"/>
               </a:lnSpc>
               <a:buNone/>
             </a:pPr>
@@ -2675,9 +2672,9 @@
                 <a:solidFill>
                   <a:srgbClr val="23283A"/>
                 </a:solidFill>
-                <a:latin typeface="Arial" pitchFamily="34" charset="0"/>
-                <a:ea typeface="Arial" pitchFamily="34" charset="-122"/>
-                <a:cs typeface="Arial" pitchFamily="34" charset="-120"/>
+                <a:latin typeface="Helvetica" pitchFamily="34" charset="0"/>
+                <a:ea typeface="Helvetica" pitchFamily="34" charset="-122"/>
+                <a:cs typeface="Helvetica" pitchFamily="34" charset="-120"/>
               </a:rPr>
               <a:t>Apa yang ingin disampaikan? Satu kalimat yang merangkum tujuan email ini.</a:t>
             </a:r>
@@ -2693,20 +2690,20 @@
         </p:nvSpPr>
         <p:spPr>
           <a:xfrm>
-            <a:off x="8001000" y="4718304"/>
-            <a:ext cx="3547872" cy="1664208"/>
+            <a:off x="8115605" y="4379732"/>
+            <a:ext cx="3527450" cy="1481145"/>
           </a:xfrm>
           <a:prstGeom prst="roundRect">
             <a:avLst>
-              <a:gd name="adj" fmla="val 5495"/>
+              <a:gd name="adj" fmla="val 6174"/>
             </a:avLst>
           </a:prstGeom>
           <a:solidFill>
-            <a:srgbClr val="EAFAF0"/>
+            <a:srgbClr val="F3F0FF"/>
           </a:solidFill>
           <a:ln w="12700">
             <a:solidFill>
-              <a:srgbClr val="D6DCEB"/>
+              <a:srgbClr val="DCD3FB"/>
             </a:solidFill>
             <a:prstDash val="solid"/>
           </a:ln>
@@ -2720,14 +2717,14 @@
         </p:nvSpPr>
         <p:spPr>
           <a:xfrm>
-            <a:off x="8165592" y="4882896"/>
+            <a:off x="8316773" y="4580900"/>
             <a:ext cx="384048" cy="384048"/>
           </a:xfrm>
           <a:prstGeom prst="ellipse">
             <a:avLst/>
           </a:prstGeom>
           <a:solidFill>
-            <a:srgbClr val="1A7A44"/>
+            <a:srgbClr val="6849F6"/>
           </a:solidFill>
           <a:ln/>
         </p:spPr>
@@ -2740,7 +2737,7 @@
         </p:nvSpPr>
         <p:spPr>
           <a:xfrm>
-            <a:off x="8165592" y="4882896"/>
+            <a:off x="8316773" y="4580900"/>
             <a:ext cx="384048" cy="384048"/>
           </a:xfrm>
           <a:prstGeom prst="rect">
@@ -2761,9 +2758,9 @@
                 <a:solidFill>
                   <a:srgbClr val="FFFFFF"/>
                 </a:solidFill>
-                <a:latin typeface="Arial" pitchFamily="34" charset="0"/>
-                <a:ea typeface="Arial" pitchFamily="34" charset="-122"/>
-                <a:cs typeface="Arial" pitchFamily="34" charset="-120"/>
+                <a:latin typeface="Helvetica" pitchFamily="34" charset="0"/>
+                <a:ea typeface="Helvetica" pitchFamily="34" charset="-122"/>
+                <a:cs typeface="Helvetica" pitchFamily="34" charset="-120"/>
               </a:rPr>
               <a:t>C</a:t>
             </a:r>
@@ -2779,8 +2776,8 @@
         </p:nvSpPr>
         <p:spPr>
           <a:xfrm>
-            <a:off x="8659368" y="4901184"/>
-            <a:ext cx="2770632" cy="320040"/>
+            <a:off x="8837981" y="4562612"/>
+            <a:ext cx="2603906" cy="310896"/>
           </a:xfrm>
           <a:prstGeom prst="rect">
             <a:avLst/>
@@ -2796,17 +2793,17 @@
               <a:buNone/>
             </a:pPr>
             <a:r>
-              <a:rPr lang="en-US" sz="1250" b="1" dirty="0">
-                <a:solidFill>
-                  <a:srgbClr val="1A7A44"/>
-                </a:solidFill>
-                <a:latin typeface="Arial" pitchFamily="34" charset="0"/>
-                <a:ea typeface="Arial" pitchFamily="34" charset="-122"/>
-                <a:cs typeface="Arial" pitchFamily="34" charset="-120"/>
+              <a:rPr lang="en-US" sz="1400" b="1" dirty="0">
+                <a:solidFill>
+                  <a:srgbClr val="0D1321"/>
+                </a:solidFill>
+                <a:latin typeface="Helvetica" pitchFamily="34" charset="0"/>
+                <a:ea typeface="Helvetica" pitchFamily="34" charset="-122"/>
+                <a:cs typeface="Helvetica" pitchFamily="34" charset="-120"/>
               </a:rPr>
               <a:t>Tone &amp; Panjang</a:t>
             </a:r>
-            <a:endParaRPr lang="en-US" sz="1250" dirty="0"/>
+            <a:endParaRPr lang="en-US" sz="1400" dirty="0"/>
           </a:p>
         </p:txBody>
       </p:sp>
@@ -2818,8 +2815,8 @@
         </p:nvSpPr>
         <p:spPr>
           <a:xfrm>
-            <a:off x="8165592" y="5312664"/>
-            <a:ext cx="3218688" cy="914400"/>
+            <a:off x="8316773" y="5001524"/>
+            <a:ext cx="3125114" cy="658185"/>
           </a:xfrm>
           <a:prstGeom prst="rect">
             <a:avLst/>
@@ -2833,7 +2830,7 @@
           <a:p>
             <a:pPr indent="0" marL="0">
               <a:lnSpc>
-                <a:spcPct val="125000"/>
+                <a:spcPct val="122000"/>
               </a:lnSpc>
               <a:buNone/>
             </a:pPr>
@@ -2842,9 +2839,9 @@
                 <a:solidFill>
                   <a:srgbClr val="23283A"/>
                 </a:solidFill>
-                <a:latin typeface="Arial" pitchFamily="34" charset="0"/>
-                <a:ea typeface="Arial" pitchFamily="34" charset="-122"/>
-                <a:cs typeface="Arial" pitchFamily="34" charset="-120"/>
+                <a:latin typeface="Helvetica" pitchFamily="34" charset="0"/>
+                <a:ea typeface="Helvetica" pitchFamily="34" charset="-122"/>
+                <a:cs typeface="Helvetica" pitchFamily="34" charset="-120"/>
               </a:rPr>
               <a:t>Formal / santai / tegas / empati? Maks berapa kata? Ada CTA atau tidak?</a:t>
             </a:r>
@@ -2863,6 +2860,13 @@
 <file path=ppt/slides/slide3.xml><?xml version="1.0" encoding="utf-8"?>
 <p:sld xmlns:a="http://schemas.openxmlformats.org/drawingml/2006/main" xmlns:r="http://schemas.openxmlformats.org/officeDocument/2006/relationships" xmlns:p="http://schemas.openxmlformats.org/presentationml/2006/main">
   <p:cSld name="Slide 3">
+    <p:bg>
+      <p:bgPr>
+        <a:solidFill>
+          <a:srgbClr val="FFFFFF"/>
+        </a:solidFill>
+      </p:bgPr>
+    </p:bg>
     <p:spTree>
       <p:nvGrpSpPr>
         <p:cNvPr id="1" name=""/>
@@ -2946,9 +2950,9 @@
                 <a:solidFill>
                   <a:srgbClr val="FFFFFF"/>
                 </a:solidFill>
-                <a:latin typeface="Arial" pitchFamily="34" charset="0"/>
-                <a:ea typeface="Arial" pitchFamily="34" charset="-122"/>
-                <a:cs typeface="Arial" pitchFamily="34" charset="-120"/>
+                <a:latin typeface="Helvetica" pitchFamily="34" charset="0"/>
+                <a:ea typeface="Helvetica" pitchFamily="34" charset="-122"/>
+                <a:cs typeface="Helvetica" pitchFamily="34" charset="-120"/>
               </a:rPr>
               <a:t>belajar</a:t>
             </a:r>
@@ -2960,9 +2964,9 @@
                 <a:solidFill>
                   <a:srgbClr val="8B7CF6"/>
                 </a:solidFill>
-                <a:latin typeface="Arial" pitchFamily="34" charset="0"/>
-                <a:ea typeface="Arial" pitchFamily="34" charset="-122"/>
-                <a:cs typeface="Arial" pitchFamily="34" charset="-120"/>
+                <a:latin typeface="Helvetica" pitchFamily="34" charset="0"/>
+                <a:ea typeface="Helvetica" pitchFamily="34" charset="-122"/>
+                <a:cs typeface="Helvetica" pitchFamily="34" charset="-120"/>
               </a:rPr>
               <a:t>claude</a:t>
             </a:r>
@@ -2999,9 +3003,9 @@
                 <a:solidFill>
                   <a:srgbClr val="9AA2B4"/>
                 </a:solidFill>
-                <a:latin typeface="Arial" pitchFamily="34" charset="0"/>
-                <a:ea typeface="Arial" pitchFamily="34" charset="-122"/>
-                <a:cs typeface="Arial" pitchFamily="34" charset="-120"/>
+                <a:latin typeface="Helvetica" pitchFamily="34" charset="0"/>
+                <a:ea typeface="Helvetica" pitchFamily="34" charset="-122"/>
+                <a:cs typeface="Helvetica" pitchFamily="34" charset="-120"/>
               </a:rPr>
               <a:t>Modul 03 — Gmail + Claude</a:t>
             </a:r>
@@ -3017,8 +3021,8 @@
         </p:nvSpPr>
         <p:spPr>
           <a:xfrm>
-            <a:off x="502920" y="1097280"/>
-            <a:ext cx="11155680" cy="548640"/>
+            <a:off x="548640" y="1188720"/>
+            <a:ext cx="11064240" cy="502920"/>
           </a:xfrm>
           <a:prstGeom prst="rect">
             <a:avLst/>
@@ -3038,9 +3042,9 @@
                 <a:solidFill>
                   <a:srgbClr val="0D1321"/>
                 </a:solidFill>
-                <a:latin typeface="Arial" pitchFamily="34" charset="0"/>
-                <a:ea typeface="Arial" pitchFamily="34" charset="-122"/>
-                <a:cs typeface="Arial" pitchFamily="34" charset="-120"/>
+                <a:latin typeface="Helvetica" pitchFamily="34" charset="0"/>
+                <a:ea typeface="Helvetica" pitchFamily="34" charset="-122"/>
+                <a:cs typeface="Helvetica" pitchFamily="34" charset="-120"/>
               </a:rPr>
               <a:t>4 Tipe Email yang Sering Ditulis</a:t>
             </a:r>
@@ -3056,8 +3060,8 @@
         </p:nvSpPr>
         <p:spPr>
           <a:xfrm>
-            <a:off x="502920" y="1737360"/>
-            <a:ext cx="11155680" cy="256032"/>
+            <a:off x="548640" y="1783080"/>
+            <a:ext cx="11094415" cy="274320"/>
           </a:xfrm>
           <a:prstGeom prst="rect">
             <a:avLst/>
@@ -3073,17 +3077,17 @@
               <a:buNone/>
             </a:pPr>
             <a:r>
-              <a:rPr lang="en-US" sz="1200" b="1" spc="30" kern="0" dirty="0">
+              <a:rPr lang="en-US" sz="1250" b="1" spc="40" kern="0" dirty="0">
                 <a:solidFill>
                   <a:srgbClr val="4B36C7"/>
                 </a:solidFill>
-                <a:latin typeface="Arial" pitchFamily="34" charset="0"/>
-                <a:ea typeface="Arial" pitchFamily="34" charset="-122"/>
-                <a:cs typeface="Arial" pitchFamily="34" charset="-120"/>
+                <a:latin typeface="Helvetica" pitchFamily="34" charset="0"/>
+                <a:ea typeface="Helvetica" pitchFamily="34" charset="-122"/>
+                <a:cs typeface="Helvetica" pitchFamily="34" charset="-120"/>
               </a:rPr>
               <a:t>TEMPLATE PROMPT UNTUK MASING-MASING TIPE</a:t>
             </a:r>
-            <a:endParaRPr lang="en-US" sz="1200" dirty="0"/>
+            <a:endParaRPr lang="en-US" sz="1250" dirty="0"/>
           </a:p>
         </p:txBody>
       </p:sp>
@@ -3095,12 +3099,12 @@
         </p:nvSpPr>
         <p:spPr>
           <a:xfrm>
-            <a:off x="502920" y="2084832"/>
-            <a:ext cx="5440680" cy="2103120"/>
+            <a:off x="548640" y="2112264"/>
+            <a:ext cx="5437480" cy="1152032"/>
           </a:xfrm>
           <a:prstGeom prst="roundRect">
             <a:avLst>
-              <a:gd name="adj" fmla="val 5217"/>
+              <a:gd name="adj" fmla="val 7937"/>
             </a:avLst>
           </a:prstGeom>
           <a:solidFill>
@@ -3122,181 +3126,152 @@
         </p:nvSpPr>
         <p:spPr>
           <a:xfrm>
-            <a:off x="667512" y="2231136"/>
-            <a:ext cx="1417320" cy="292608"/>
+            <a:off x="731520" y="2295144"/>
+            <a:ext cx="365760" cy="365760"/>
+          </a:xfrm>
+          <a:prstGeom prst="ellipse">
+            <a:avLst/>
+          </a:prstGeom>
+          <a:solidFill>
+            <a:srgbClr val="6849F6"/>
+          </a:solidFill>
+          <a:ln/>
+        </p:spPr>
+      </p:sp>
+      <p:sp>
+        <p:nvSpPr>
+          <p:cNvPr id="10" name="Text 8"/>
+          <p:cNvSpPr/>
+          <p:nvPr/>
+        </p:nvSpPr>
+        <p:spPr>
+          <a:xfrm>
+            <a:off x="731520" y="2295144"/>
+            <a:ext cx="365760" cy="365760"/>
+          </a:xfrm>
+          <a:prstGeom prst="rect">
+            <a:avLst/>
+          </a:prstGeom>
+          <a:noFill/>
+          <a:ln/>
+        </p:spPr>
+        <p:txBody>
+          <a:bodyPr wrap="square" lIns="0" tIns="0" rIns="0" bIns="0" rtlCol="0" anchor="ctr"/>
+          <a:lstStyle/>
+          <a:p>
+            <a:pPr algn="ctr" indent="0" marL="0">
+              <a:buNone/>
+            </a:pPr>
+            <a:r>
+              <a:rPr lang="en-US" sz="1400" b="1" dirty="0">
+                <a:solidFill>
+                  <a:srgbClr val="FFFFFF"/>
+                </a:solidFill>
+                <a:latin typeface="Helvetica" pitchFamily="34" charset="0"/>
+                <a:ea typeface="Helvetica" pitchFamily="34" charset="-122"/>
+                <a:cs typeface="Helvetica" pitchFamily="34" charset="-120"/>
+              </a:rPr>
+              <a:t>1</a:t>
+            </a:r>
+            <a:endParaRPr lang="en-US" sz="1400" dirty="0"/>
+          </a:p>
+        </p:txBody>
+      </p:sp>
+      <p:sp>
+        <p:nvSpPr>
+          <p:cNvPr id="11" name="Text 9"/>
+          <p:cNvSpPr/>
+          <p:nvPr/>
+        </p:nvSpPr>
+        <p:spPr>
+          <a:xfrm>
+            <a:off x="1225296" y="2267712"/>
+            <a:ext cx="4577944" cy="310896"/>
+          </a:xfrm>
+          <a:prstGeom prst="rect">
+            <a:avLst/>
+          </a:prstGeom>
+          <a:noFill/>
+          <a:ln/>
+        </p:spPr>
+        <p:txBody>
+          <a:bodyPr wrap="square" lIns="0" tIns="0" rIns="0" bIns="0" rtlCol="0" anchor="ctr"/>
+          <a:lstStyle/>
+          <a:p>
+            <a:pPr indent="0" marL="0">
+              <a:buNone/>
+            </a:pPr>
+            <a:r>
+              <a:rPr lang="en-US" sz="1300" b="1" dirty="0">
+                <a:solidFill>
+                  <a:srgbClr val="0D1321"/>
+                </a:solidFill>
+                <a:latin typeface="Helvetica" pitchFamily="34" charset="0"/>
+                <a:ea typeface="Helvetica" pitchFamily="34" charset="-122"/>
+                <a:cs typeface="Helvetica" pitchFamily="34" charset="-120"/>
+              </a:rPr>
+              <a:t>Balas Pertanyaan / Inquiry</a:t>
+            </a:r>
+            <a:endParaRPr lang="en-US" sz="1300" dirty="0"/>
+          </a:p>
+        </p:txBody>
+      </p:sp>
+      <p:sp>
+        <p:nvSpPr>
+          <p:cNvPr id="12" name="Text 10"/>
+          <p:cNvSpPr/>
+          <p:nvPr/>
+        </p:nvSpPr>
+        <p:spPr>
+          <a:xfrm>
+            <a:off x="731520" y="2679192"/>
+            <a:ext cx="5071720" cy="402224"/>
+          </a:xfrm>
+          <a:prstGeom prst="rect">
+            <a:avLst/>
+          </a:prstGeom>
+          <a:noFill/>
+          <a:ln/>
+        </p:spPr>
+        <p:txBody>
+          <a:bodyPr wrap="square" lIns="0" tIns="0" rIns="0" bIns="0" rtlCol="0" anchor="t"/>
+          <a:lstStyle/>
+          <a:p>
+            <a:pPr indent="0" marL="0">
+              <a:lnSpc>
+                <a:spcPct val="122000"/>
+              </a:lnSpc>
+              <a:buNone/>
+            </a:pPr>
+            <a:r>
+              <a:rPr lang="en-US" sz="1100" dirty="0">
+                <a:solidFill>
+                  <a:srgbClr val="23283A"/>
+                </a:solidFill>
+                <a:latin typeface="Helvetica" pitchFamily="34" charset="0"/>
+                <a:ea typeface="Helvetica" pitchFamily="34" charset="-122"/>
+                <a:cs typeface="Helvetica" pitchFamily="34" charset="-120"/>
+              </a:rPr>
+              <a:t>Balas email dari [nama] yang tanya tentang [topik]. Berikan info lengkap tapi singkat. Tone: ramah-profesional. Maks 80 kata.</a:t>
+            </a:r>
+            <a:endParaRPr lang="en-US" sz="1100" dirty="0"/>
+          </a:p>
+        </p:txBody>
+      </p:sp>
+      <p:sp>
+        <p:nvSpPr>
+          <p:cNvPr id="13" name="Shape 11"/>
+          <p:cNvSpPr/>
+          <p:nvPr/>
+        </p:nvSpPr>
+        <p:spPr>
+          <a:xfrm>
+            <a:off x="6205576" y="2112264"/>
+            <a:ext cx="5437480" cy="1152032"/>
           </a:xfrm>
           <a:prstGeom prst="roundRect">
             <a:avLst>
-              <a:gd name="adj" fmla="val 21875"/>
-            </a:avLst>
-          </a:prstGeom>
-          <a:solidFill>
-            <a:srgbClr val="6849F6"/>
-          </a:solidFill>
-          <a:ln/>
-        </p:spPr>
-      </p:sp>
-      <p:sp>
-        <p:nvSpPr>
-          <p:cNvPr id="10" name="Text 8"/>
-          <p:cNvSpPr/>
-          <p:nvPr/>
-        </p:nvSpPr>
-        <p:spPr>
-          <a:xfrm>
-            <a:off x="667512" y="2231136"/>
-            <a:ext cx="1417320" cy="292608"/>
-          </a:xfrm>
-          <a:prstGeom prst="rect">
-            <a:avLst/>
-          </a:prstGeom>
-          <a:noFill/>
-          <a:ln/>
-        </p:spPr>
-        <p:txBody>
-          <a:bodyPr wrap="square" lIns="0" tIns="0" rIns="0" bIns="0" rtlCol="0" anchor="ctr"/>
-          <a:lstStyle/>
-          <a:p>
-            <a:pPr algn="ctr" indent="0" marL="0">
-              <a:buNone/>
-            </a:pPr>
-            <a:r>
-              <a:rPr lang="en-US" sz="950" b="1" dirty="0">
-                <a:solidFill>
-                  <a:srgbClr val="FFFFFF"/>
-                </a:solidFill>
-                <a:latin typeface="Arial" pitchFamily="34" charset="0"/>
-                <a:ea typeface="Arial" pitchFamily="34" charset="-122"/>
-                <a:cs typeface="Arial" pitchFamily="34" charset="-120"/>
-              </a:rPr>
-              <a:t>PALING SERING</a:t>
-            </a:r>
-            <a:endParaRPr lang="en-US" sz="950" dirty="0"/>
-          </a:p>
-        </p:txBody>
-      </p:sp>
-      <p:sp>
-        <p:nvSpPr>
-          <p:cNvPr id="11" name="Text 9"/>
-          <p:cNvSpPr/>
-          <p:nvPr/>
-        </p:nvSpPr>
-        <p:spPr>
-          <a:xfrm>
-            <a:off x="2194560" y="2240280"/>
-            <a:ext cx="3566160" cy="292608"/>
-          </a:xfrm>
-          <a:prstGeom prst="rect">
-            <a:avLst/>
-          </a:prstGeom>
-          <a:noFill/>
-          <a:ln/>
-        </p:spPr>
-        <p:txBody>
-          <a:bodyPr wrap="square" lIns="0" tIns="0" rIns="0" bIns="0" rtlCol="0" anchor="ctr"/>
-          <a:lstStyle/>
-          <a:p>
-            <a:pPr indent="0" marL="0">
-              <a:buNone/>
-            </a:pPr>
-            <a:r>
-              <a:rPr lang="en-US" sz="1250" b="1" dirty="0">
-                <a:solidFill>
-                  <a:srgbClr val="0D1321"/>
-                </a:solidFill>
-                <a:latin typeface="Arial" pitchFamily="34" charset="0"/>
-                <a:ea typeface="Arial" pitchFamily="34" charset="-122"/>
-                <a:cs typeface="Arial" pitchFamily="34" charset="-120"/>
-              </a:rPr>
-              <a:t>Balas Pertanyaan / Inquiry</a:t>
-            </a:r>
-            <a:endParaRPr lang="en-US" sz="1250" dirty="0"/>
-          </a:p>
-        </p:txBody>
-      </p:sp>
-      <p:sp>
-        <p:nvSpPr>
-          <p:cNvPr id="12" name="Shape 10"/>
-          <p:cNvSpPr/>
-          <p:nvPr/>
-        </p:nvSpPr>
-        <p:spPr>
-          <a:xfrm>
-            <a:off x="667512" y="2633472"/>
-            <a:ext cx="5111496" cy="1417320"/>
-          </a:xfrm>
-          <a:prstGeom prst="roundRect">
-            <a:avLst>
-              <a:gd name="adj" fmla="val 5161"/>
-            </a:avLst>
-          </a:prstGeom>
-          <a:solidFill>
-            <a:srgbClr val="0D1321"/>
-          </a:solidFill>
-          <a:ln w="9525">
-            <a:solidFill>
-              <a:srgbClr val="6849F6"/>
-            </a:solidFill>
-            <a:prstDash val="solid"/>
-          </a:ln>
-        </p:spPr>
-      </p:sp>
-      <p:sp>
-        <p:nvSpPr>
-          <p:cNvPr id="13" name="Text 11"/>
-          <p:cNvSpPr/>
-          <p:nvPr/>
-        </p:nvSpPr>
-        <p:spPr>
-          <a:xfrm>
-            <a:off x="822960" y="2724912"/>
-            <a:ext cx="4846320" cy="1234440"/>
-          </a:xfrm>
-          <a:prstGeom prst="rect">
-            <a:avLst/>
-          </a:prstGeom>
-          <a:noFill/>
-          <a:ln/>
-        </p:spPr>
-        <p:txBody>
-          <a:bodyPr wrap="square" lIns="0" tIns="0" rIns="0" bIns="0" rtlCol="0" anchor="t"/>
-          <a:lstStyle/>
-          <a:p>
-            <a:pPr indent="0" marL="0">
-              <a:lnSpc>
-                <a:spcPct val="130000"/>
-              </a:lnSpc>
-              <a:buNone/>
-            </a:pPr>
-            <a:r>
-              <a:rPr lang="en-US" sz="1150" i="1" dirty="0">
-                <a:solidFill>
-                  <a:srgbClr val="FFFFFF"/>
-                </a:solidFill>
-                <a:latin typeface="Arial" pitchFamily="34" charset="0"/>
-                <a:ea typeface="Arial" pitchFamily="34" charset="-122"/>
-                <a:cs typeface="Arial" pitchFamily="34" charset="-120"/>
-              </a:rPr>
-              <a:t>Balas email dari [nama] yang tanya tentang [topik]. Berikan info lengkap tapi singkat. Tone: ramah-profesional. Maks 80 kata.</a:t>
-            </a:r>
-            <a:endParaRPr lang="en-US" sz="1150" dirty="0"/>
-          </a:p>
-        </p:txBody>
-      </p:sp>
-      <p:sp>
-        <p:nvSpPr>
-          <p:cNvPr id="14" name="Shape 12"/>
-          <p:cNvSpPr/>
-          <p:nvPr/>
-        </p:nvSpPr>
-        <p:spPr>
-          <a:xfrm>
-            <a:off x="6345936" y="2084832"/>
-            <a:ext cx="5440680" cy="2103120"/>
-          </a:xfrm>
-          <a:prstGeom prst="roundRect">
-            <a:avLst>
-              <a:gd name="adj" fmla="val 5217"/>
+              <a:gd name="adj" fmla="val 7937"/>
             </a:avLst>
           </a:prstGeom>
           <a:solidFill>
@@ -3312,187 +3287,158 @@
       </p:sp>
       <p:sp>
         <p:nvSpPr>
-          <p:cNvPr id="15" name="Shape 13"/>
-          <p:cNvSpPr/>
-          <p:nvPr/>
-        </p:nvSpPr>
-        <p:spPr>
-          <a:xfrm>
-            <a:off x="6510528" y="2231136"/>
-            <a:ext cx="1417320" cy="292608"/>
+          <p:cNvPr id="14" name="Shape 12"/>
+          <p:cNvSpPr/>
+          <p:nvPr/>
+        </p:nvSpPr>
+        <p:spPr>
+          <a:xfrm>
+            <a:off x="6388456" y="2295144"/>
+            <a:ext cx="365760" cy="365760"/>
+          </a:xfrm>
+          <a:prstGeom prst="ellipse">
+            <a:avLst/>
+          </a:prstGeom>
+          <a:solidFill>
+            <a:srgbClr val="6849F6"/>
+          </a:solidFill>
+          <a:ln/>
+        </p:spPr>
+      </p:sp>
+      <p:sp>
+        <p:nvSpPr>
+          <p:cNvPr id="15" name="Text 13"/>
+          <p:cNvSpPr/>
+          <p:nvPr/>
+        </p:nvSpPr>
+        <p:spPr>
+          <a:xfrm>
+            <a:off x="6388456" y="2295144"/>
+            <a:ext cx="365760" cy="365760"/>
+          </a:xfrm>
+          <a:prstGeom prst="rect">
+            <a:avLst/>
+          </a:prstGeom>
+          <a:noFill/>
+          <a:ln/>
+        </p:spPr>
+        <p:txBody>
+          <a:bodyPr wrap="square" lIns="0" tIns="0" rIns="0" bIns="0" rtlCol="0" anchor="ctr"/>
+          <a:lstStyle/>
+          <a:p>
+            <a:pPr algn="ctr" indent="0" marL="0">
+              <a:buNone/>
+            </a:pPr>
+            <a:r>
+              <a:rPr lang="en-US" sz="1400" b="1" dirty="0">
+                <a:solidFill>
+                  <a:srgbClr val="FFFFFF"/>
+                </a:solidFill>
+                <a:latin typeface="Helvetica" pitchFamily="34" charset="0"/>
+                <a:ea typeface="Helvetica" pitchFamily="34" charset="-122"/>
+                <a:cs typeface="Helvetica" pitchFamily="34" charset="-120"/>
+              </a:rPr>
+              <a:t>2</a:t>
+            </a:r>
+            <a:endParaRPr lang="en-US" sz="1400" dirty="0"/>
+          </a:p>
+        </p:txBody>
+      </p:sp>
+      <p:sp>
+        <p:nvSpPr>
+          <p:cNvPr id="16" name="Text 14"/>
+          <p:cNvSpPr/>
+          <p:nvPr/>
+        </p:nvSpPr>
+        <p:spPr>
+          <a:xfrm>
+            <a:off x="6882232" y="2267712"/>
+            <a:ext cx="4577944" cy="310896"/>
+          </a:xfrm>
+          <a:prstGeom prst="rect">
+            <a:avLst/>
+          </a:prstGeom>
+          <a:noFill/>
+          <a:ln/>
+        </p:spPr>
+        <p:txBody>
+          <a:bodyPr wrap="square" lIns="0" tIns="0" rIns="0" bIns="0" rtlCol="0" anchor="ctr"/>
+          <a:lstStyle/>
+          <a:p>
+            <a:pPr indent="0" marL="0">
+              <a:buNone/>
+            </a:pPr>
+            <a:r>
+              <a:rPr lang="en-US" sz="1300" b="1" dirty="0">
+                <a:solidFill>
+                  <a:srgbClr val="0D1321"/>
+                </a:solidFill>
+                <a:latin typeface="Helvetica" pitchFamily="34" charset="0"/>
+                <a:ea typeface="Helvetica" pitchFamily="34" charset="-122"/>
+                <a:cs typeface="Helvetica" pitchFamily="34" charset="-120"/>
+              </a:rPr>
+              <a:t>Menangani Komplain</a:t>
+            </a:r>
+            <a:endParaRPr lang="en-US" sz="1300" dirty="0"/>
+          </a:p>
+        </p:txBody>
+      </p:sp>
+      <p:sp>
+        <p:nvSpPr>
+          <p:cNvPr id="17" name="Text 15"/>
+          <p:cNvSpPr/>
+          <p:nvPr/>
+        </p:nvSpPr>
+        <p:spPr>
+          <a:xfrm>
+            <a:off x="6388456" y="2679192"/>
+            <a:ext cx="5071720" cy="402224"/>
+          </a:xfrm>
+          <a:prstGeom prst="rect">
+            <a:avLst/>
+          </a:prstGeom>
+          <a:noFill/>
+          <a:ln/>
+        </p:spPr>
+        <p:txBody>
+          <a:bodyPr wrap="square" lIns="0" tIns="0" rIns="0" bIns="0" rtlCol="0" anchor="t"/>
+          <a:lstStyle/>
+          <a:p>
+            <a:pPr indent="0" marL="0">
+              <a:lnSpc>
+                <a:spcPct val="122000"/>
+              </a:lnSpc>
+              <a:buNone/>
+            </a:pPr>
+            <a:r>
+              <a:rPr lang="en-US" sz="1100" dirty="0">
+                <a:solidFill>
+                  <a:srgbClr val="23283A"/>
+                </a:solidFill>
+                <a:latin typeface="Helvetica" pitchFamily="34" charset="0"/>
+                <a:ea typeface="Helvetica" pitchFamily="34" charset="-122"/>
+                <a:cs typeface="Helvetica" pitchFamily="34" charset="-120"/>
+              </a:rPr>
+              <a:t>Balas komplain dari [nama] soal [masalah]. Mulai dengan empati, akui masalahnya, tawarkan solusi [sebutkan]. Tone: hangat, tidak defensif.</a:t>
+            </a:r>
+            <a:endParaRPr lang="en-US" sz="1100" dirty="0"/>
+          </a:p>
+        </p:txBody>
+      </p:sp>
+      <p:sp>
+        <p:nvSpPr>
+          <p:cNvPr id="18" name="Shape 16"/>
+          <p:cNvSpPr/>
+          <p:nvPr/>
+        </p:nvSpPr>
+        <p:spPr>
+          <a:xfrm>
+            <a:off x="548640" y="3447176"/>
+            <a:ext cx="5437480" cy="1152032"/>
           </a:xfrm>
           <a:prstGeom prst="roundRect">
             <a:avLst>
-              <a:gd name="adj" fmla="val 21875"/>
-            </a:avLst>
-          </a:prstGeom>
-          <a:solidFill>
-            <a:srgbClr val="FEE2E2"/>
-          </a:solidFill>
-          <a:ln/>
-        </p:spPr>
-      </p:sp>
-      <p:sp>
-        <p:nvSpPr>
-          <p:cNvPr id="16" name="Text 14"/>
-          <p:cNvSpPr/>
-          <p:nvPr/>
-        </p:nvSpPr>
-        <p:spPr>
-          <a:xfrm>
-            <a:off x="6510528" y="2231136"/>
-            <a:ext cx="1417320" cy="292608"/>
-          </a:xfrm>
-          <a:prstGeom prst="rect">
-            <a:avLst/>
-          </a:prstGeom>
-          <a:noFill/>
-          <a:ln/>
-        </p:spPr>
-        <p:txBody>
-          <a:bodyPr wrap="square" lIns="0" tIns="0" rIns="0" bIns="0" rtlCol="0" anchor="ctr"/>
-          <a:lstStyle/>
-          <a:p>
-            <a:pPr algn="ctr" indent="0" marL="0">
-              <a:buNone/>
-            </a:pPr>
-            <a:r>
-              <a:rPr lang="en-US" sz="950" b="1" dirty="0">
-                <a:solidFill>
-                  <a:srgbClr val="991B1B"/>
-                </a:solidFill>
-                <a:latin typeface="Arial" pitchFamily="34" charset="0"/>
-                <a:ea typeface="Arial" pitchFamily="34" charset="-122"/>
-                <a:cs typeface="Arial" pitchFamily="34" charset="-120"/>
-              </a:rPr>
-              <a:t>HIGH PRIORITY</a:t>
-            </a:r>
-            <a:endParaRPr lang="en-US" sz="950" dirty="0"/>
-          </a:p>
-        </p:txBody>
-      </p:sp>
-      <p:sp>
-        <p:nvSpPr>
-          <p:cNvPr id="17" name="Text 15"/>
-          <p:cNvSpPr/>
-          <p:nvPr/>
-        </p:nvSpPr>
-        <p:spPr>
-          <a:xfrm>
-            <a:off x="8037576" y="2240280"/>
-            <a:ext cx="3566160" cy="292608"/>
-          </a:xfrm>
-          <a:prstGeom prst="rect">
-            <a:avLst/>
-          </a:prstGeom>
-          <a:noFill/>
-          <a:ln/>
-        </p:spPr>
-        <p:txBody>
-          <a:bodyPr wrap="square" lIns="0" tIns="0" rIns="0" bIns="0" rtlCol="0" anchor="ctr"/>
-          <a:lstStyle/>
-          <a:p>
-            <a:pPr indent="0" marL="0">
-              <a:buNone/>
-            </a:pPr>
-            <a:r>
-              <a:rPr lang="en-US" sz="1250" b="1" dirty="0">
-                <a:solidFill>
-                  <a:srgbClr val="0D1321"/>
-                </a:solidFill>
-                <a:latin typeface="Arial" pitchFamily="34" charset="0"/>
-                <a:ea typeface="Arial" pitchFamily="34" charset="-122"/>
-                <a:cs typeface="Arial" pitchFamily="34" charset="-120"/>
-              </a:rPr>
-              <a:t>Menangani Komplain</a:t>
-            </a:r>
-            <a:endParaRPr lang="en-US" sz="1250" dirty="0"/>
-          </a:p>
-        </p:txBody>
-      </p:sp>
-      <p:sp>
-        <p:nvSpPr>
-          <p:cNvPr id="18" name="Shape 16"/>
-          <p:cNvSpPr/>
-          <p:nvPr/>
-        </p:nvSpPr>
-        <p:spPr>
-          <a:xfrm>
-            <a:off x="6510528" y="2633472"/>
-            <a:ext cx="5111496" cy="1417320"/>
-          </a:xfrm>
-          <a:prstGeom prst="roundRect">
-            <a:avLst>
-              <a:gd name="adj" fmla="val 5161"/>
-            </a:avLst>
-          </a:prstGeom>
-          <a:solidFill>
-            <a:srgbClr val="0D1321"/>
-          </a:solidFill>
-          <a:ln w="9525">
-            <a:solidFill>
-              <a:srgbClr val="6849F6"/>
-            </a:solidFill>
-            <a:prstDash val="solid"/>
-          </a:ln>
-        </p:spPr>
-      </p:sp>
-      <p:sp>
-        <p:nvSpPr>
-          <p:cNvPr id="19" name="Text 17"/>
-          <p:cNvSpPr/>
-          <p:nvPr/>
-        </p:nvSpPr>
-        <p:spPr>
-          <a:xfrm>
-            <a:off x="6665976" y="2724912"/>
-            <a:ext cx="4846320" cy="1234440"/>
-          </a:xfrm>
-          <a:prstGeom prst="rect">
-            <a:avLst/>
-          </a:prstGeom>
-          <a:noFill/>
-          <a:ln/>
-        </p:spPr>
-        <p:txBody>
-          <a:bodyPr wrap="square" lIns="0" tIns="0" rIns="0" bIns="0" rtlCol="0" anchor="t"/>
-          <a:lstStyle/>
-          <a:p>
-            <a:pPr indent="0" marL="0">
-              <a:lnSpc>
-                <a:spcPct val="130000"/>
-              </a:lnSpc>
-              <a:buNone/>
-            </a:pPr>
-            <a:r>
-              <a:rPr lang="en-US" sz="1150" i="1" dirty="0">
-                <a:solidFill>
-                  <a:srgbClr val="FFFFFF"/>
-                </a:solidFill>
-                <a:latin typeface="Arial" pitchFamily="34" charset="0"/>
-                <a:ea typeface="Arial" pitchFamily="34" charset="-122"/>
-                <a:cs typeface="Arial" pitchFamily="34" charset="-120"/>
-              </a:rPr>
-              <a:t>Balas komplain dari [nama] soal [masalah]. Mulai dengan empati, akui masalahnya, tawarkan solusi [sebutkan]. Tone: hangat, tidak defensif.</a:t>
-            </a:r>
-            <a:endParaRPr lang="en-US" sz="1150" dirty="0"/>
-          </a:p>
-        </p:txBody>
-      </p:sp>
-      <p:sp>
-        <p:nvSpPr>
-          <p:cNvPr id="20" name="Shape 18"/>
-          <p:cNvSpPr/>
-          <p:nvPr/>
-        </p:nvSpPr>
-        <p:spPr>
-          <a:xfrm>
-            <a:off x="502920" y="4389120"/>
-            <a:ext cx="5440680" cy="2103120"/>
-          </a:xfrm>
-          <a:prstGeom prst="roundRect">
-            <a:avLst>
-              <a:gd name="adj" fmla="val 5217"/>
+              <a:gd name="adj" fmla="val 7937"/>
             </a:avLst>
           </a:prstGeom>
           <a:solidFill>
@@ -3508,187 +3454,158 @@
       </p:sp>
       <p:sp>
         <p:nvSpPr>
-          <p:cNvPr id="21" name="Shape 19"/>
-          <p:cNvSpPr/>
-          <p:nvPr/>
-        </p:nvSpPr>
-        <p:spPr>
-          <a:xfrm>
-            <a:off x="667512" y="4535424"/>
-            <a:ext cx="1417320" cy="292608"/>
+          <p:cNvPr id="19" name="Shape 17"/>
+          <p:cNvSpPr/>
+          <p:nvPr/>
+        </p:nvSpPr>
+        <p:spPr>
+          <a:xfrm>
+            <a:off x="731520" y="3630056"/>
+            <a:ext cx="365760" cy="365760"/>
+          </a:xfrm>
+          <a:prstGeom prst="ellipse">
+            <a:avLst/>
+          </a:prstGeom>
+          <a:solidFill>
+            <a:srgbClr val="6849F6"/>
+          </a:solidFill>
+          <a:ln/>
+        </p:spPr>
+      </p:sp>
+      <p:sp>
+        <p:nvSpPr>
+          <p:cNvPr id="20" name="Text 18"/>
+          <p:cNvSpPr/>
+          <p:nvPr/>
+        </p:nvSpPr>
+        <p:spPr>
+          <a:xfrm>
+            <a:off x="731520" y="3630056"/>
+            <a:ext cx="365760" cy="365760"/>
+          </a:xfrm>
+          <a:prstGeom prst="rect">
+            <a:avLst/>
+          </a:prstGeom>
+          <a:noFill/>
+          <a:ln/>
+        </p:spPr>
+        <p:txBody>
+          <a:bodyPr wrap="square" lIns="0" tIns="0" rIns="0" bIns="0" rtlCol="0" anchor="ctr"/>
+          <a:lstStyle/>
+          <a:p>
+            <a:pPr algn="ctr" indent="0" marL="0">
+              <a:buNone/>
+            </a:pPr>
+            <a:r>
+              <a:rPr lang="en-US" sz="1400" b="1" dirty="0">
+                <a:solidFill>
+                  <a:srgbClr val="FFFFFF"/>
+                </a:solidFill>
+                <a:latin typeface="Helvetica" pitchFamily="34" charset="0"/>
+                <a:ea typeface="Helvetica" pitchFamily="34" charset="-122"/>
+                <a:cs typeface="Helvetica" pitchFamily="34" charset="-120"/>
+              </a:rPr>
+              <a:t>3</a:t>
+            </a:r>
+            <a:endParaRPr lang="en-US" sz="1400" dirty="0"/>
+          </a:p>
+        </p:txBody>
+      </p:sp>
+      <p:sp>
+        <p:nvSpPr>
+          <p:cNvPr id="21" name="Text 19"/>
+          <p:cNvSpPr/>
+          <p:nvPr/>
+        </p:nvSpPr>
+        <p:spPr>
+          <a:xfrm>
+            <a:off x="1225296" y="3602624"/>
+            <a:ext cx="4577944" cy="310896"/>
+          </a:xfrm>
+          <a:prstGeom prst="rect">
+            <a:avLst/>
+          </a:prstGeom>
+          <a:noFill/>
+          <a:ln/>
+        </p:spPr>
+        <p:txBody>
+          <a:bodyPr wrap="square" lIns="0" tIns="0" rIns="0" bIns="0" rtlCol="0" anchor="ctr"/>
+          <a:lstStyle/>
+          <a:p>
+            <a:pPr indent="0" marL="0">
+              <a:buNone/>
+            </a:pPr>
+            <a:r>
+              <a:rPr lang="en-US" sz="1300" b="1" dirty="0">
+                <a:solidFill>
+                  <a:srgbClr val="0D1321"/>
+                </a:solidFill>
+                <a:latin typeface="Helvetica" pitchFamily="34" charset="0"/>
+                <a:ea typeface="Helvetica" pitchFamily="34" charset="-122"/>
+                <a:cs typeface="Helvetica" pitchFamily="34" charset="-120"/>
+              </a:rPr>
+              <a:t>Follow-up &amp; Pengingat</a:t>
+            </a:r>
+            <a:endParaRPr lang="en-US" sz="1300" dirty="0"/>
+          </a:p>
+        </p:txBody>
+      </p:sp>
+      <p:sp>
+        <p:nvSpPr>
+          <p:cNvPr id="22" name="Text 20"/>
+          <p:cNvSpPr/>
+          <p:nvPr/>
+        </p:nvSpPr>
+        <p:spPr>
+          <a:xfrm>
+            <a:off x="731520" y="4014104"/>
+            <a:ext cx="5071720" cy="402224"/>
+          </a:xfrm>
+          <a:prstGeom prst="rect">
+            <a:avLst/>
+          </a:prstGeom>
+          <a:noFill/>
+          <a:ln/>
+        </p:spPr>
+        <p:txBody>
+          <a:bodyPr wrap="square" lIns="0" tIns="0" rIns="0" bIns="0" rtlCol="0" anchor="t"/>
+          <a:lstStyle/>
+          <a:p>
+            <a:pPr indent="0" marL="0">
+              <a:lnSpc>
+                <a:spcPct val="122000"/>
+              </a:lnSpc>
+              <a:buNone/>
+            </a:pPr>
+            <a:r>
+              <a:rPr lang="en-US" sz="1100" dirty="0">
+                <a:solidFill>
+                  <a:srgbClr val="23283A"/>
+                </a:solidFill>
+                <a:latin typeface="Helvetica" pitchFamily="34" charset="0"/>
+                <a:ea typeface="Helvetica" pitchFamily="34" charset="-122"/>
+                <a:cs typeface="Helvetica" pitchFamily="34" charset="-120"/>
+              </a:rPr>
+              <a:t>Kirim follow-up ke [nama] soal [topik] yang belum direspons sejak [tanggal]. Tone: sopan, gentle reminder. Jangan terkesan mendesak.</a:t>
+            </a:r>
+            <a:endParaRPr lang="en-US" sz="1100" dirty="0"/>
+          </a:p>
+        </p:txBody>
+      </p:sp>
+      <p:sp>
+        <p:nvSpPr>
+          <p:cNvPr id="23" name="Shape 21"/>
+          <p:cNvSpPr/>
+          <p:nvPr/>
+        </p:nvSpPr>
+        <p:spPr>
+          <a:xfrm>
+            <a:off x="6205576" y="3447176"/>
+            <a:ext cx="5437480" cy="1152032"/>
           </a:xfrm>
           <a:prstGeom prst="roundRect">
             <a:avLst>
-              <a:gd name="adj" fmla="val 21875"/>
-            </a:avLst>
-          </a:prstGeom>
-          <a:solidFill>
-            <a:srgbClr val="EAFAF0"/>
-          </a:solidFill>
-          <a:ln/>
-        </p:spPr>
-      </p:sp>
-      <p:sp>
-        <p:nvSpPr>
-          <p:cNvPr id="22" name="Text 20"/>
-          <p:cNvSpPr/>
-          <p:nvPr/>
-        </p:nvSpPr>
-        <p:spPr>
-          <a:xfrm>
-            <a:off x="667512" y="4535424"/>
-            <a:ext cx="1417320" cy="292608"/>
-          </a:xfrm>
-          <a:prstGeom prst="rect">
-            <a:avLst/>
-          </a:prstGeom>
-          <a:noFill/>
-          <a:ln/>
-        </p:spPr>
-        <p:txBody>
-          <a:bodyPr wrap="square" lIns="0" tIns="0" rIns="0" bIns="0" rtlCol="0" anchor="ctr"/>
-          <a:lstStyle/>
-          <a:p>
-            <a:pPr algn="ctr" indent="0" marL="0">
-              <a:buNone/>
-            </a:pPr>
-            <a:r>
-              <a:rPr lang="en-US" sz="950" b="1" dirty="0">
-                <a:solidFill>
-                  <a:srgbClr val="1A7A44"/>
-                </a:solidFill>
-                <a:latin typeface="Arial" pitchFamily="34" charset="0"/>
-                <a:ea typeface="Arial" pitchFamily="34" charset="-122"/>
-                <a:cs typeface="Arial" pitchFamily="34" charset="-120"/>
-              </a:rPr>
-              <a:t>PENTING</a:t>
-            </a:r>
-            <a:endParaRPr lang="en-US" sz="950" dirty="0"/>
-          </a:p>
-        </p:txBody>
-      </p:sp>
-      <p:sp>
-        <p:nvSpPr>
-          <p:cNvPr id="23" name="Text 21"/>
-          <p:cNvSpPr/>
-          <p:nvPr/>
-        </p:nvSpPr>
-        <p:spPr>
-          <a:xfrm>
-            <a:off x="2194560" y="4544568"/>
-            <a:ext cx="3566160" cy="292608"/>
-          </a:xfrm>
-          <a:prstGeom prst="rect">
-            <a:avLst/>
-          </a:prstGeom>
-          <a:noFill/>
-          <a:ln/>
-        </p:spPr>
-        <p:txBody>
-          <a:bodyPr wrap="square" lIns="0" tIns="0" rIns="0" bIns="0" rtlCol="0" anchor="ctr"/>
-          <a:lstStyle/>
-          <a:p>
-            <a:pPr indent="0" marL="0">
-              <a:buNone/>
-            </a:pPr>
-            <a:r>
-              <a:rPr lang="en-US" sz="1250" b="1" dirty="0">
-                <a:solidFill>
-                  <a:srgbClr val="0D1321"/>
-                </a:solidFill>
-                <a:latin typeface="Arial" pitchFamily="34" charset="0"/>
-                <a:ea typeface="Arial" pitchFamily="34" charset="-122"/>
-                <a:cs typeface="Arial" pitchFamily="34" charset="-120"/>
-              </a:rPr>
-              <a:t>Follow-up &amp; Pengingat</a:t>
-            </a:r>
-            <a:endParaRPr lang="en-US" sz="1250" dirty="0"/>
-          </a:p>
-        </p:txBody>
-      </p:sp>
-      <p:sp>
-        <p:nvSpPr>
-          <p:cNvPr id="24" name="Shape 22"/>
-          <p:cNvSpPr/>
-          <p:nvPr/>
-        </p:nvSpPr>
-        <p:spPr>
-          <a:xfrm>
-            <a:off x="667512" y="4937760"/>
-            <a:ext cx="5111496" cy="1417320"/>
-          </a:xfrm>
-          <a:prstGeom prst="roundRect">
-            <a:avLst>
-              <a:gd name="adj" fmla="val 5161"/>
-            </a:avLst>
-          </a:prstGeom>
-          <a:solidFill>
-            <a:srgbClr val="0D1321"/>
-          </a:solidFill>
-          <a:ln w="9525">
-            <a:solidFill>
-              <a:srgbClr val="6849F6"/>
-            </a:solidFill>
-            <a:prstDash val="solid"/>
-          </a:ln>
-        </p:spPr>
-      </p:sp>
-      <p:sp>
-        <p:nvSpPr>
-          <p:cNvPr id="25" name="Text 23"/>
-          <p:cNvSpPr/>
-          <p:nvPr/>
-        </p:nvSpPr>
-        <p:spPr>
-          <a:xfrm>
-            <a:off x="822960" y="5029200"/>
-            <a:ext cx="4846320" cy="1234440"/>
-          </a:xfrm>
-          <a:prstGeom prst="rect">
-            <a:avLst/>
-          </a:prstGeom>
-          <a:noFill/>
-          <a:ln/>
-        </p:spPr>
-        <p:txBody>
-          <a:bodyPr wrap="square" lIns="0" tIns="0" rIns="0" bIns="0" rtlCol="0" anchor="t"/>
-          <a:lstStyle/>
-          <a:p>
-            <a:pPr indent="0" marL="0">
-              <a:lnSpc>
-                <a:spcPct val="130000"/>
-              </a:lnSpc>
-              <a:buNone/>
-            </a:pPr>
-            <a:r>
-              <a:rPr lang="en-US" sz="1150" i="1" dirty="0">
-                <a:solidFill>
-                  <a:srgbClr val="FFFFFF"/>
-                </a:solidFill>
-                <a:latin typeface="Arial" pitchFamily="34" charset="0"/>
-                <a:ea typeface="Arial" pitchFamily="34" charset="-122"/>
-                <a:cs typeface="Arial" pitchFamily="34" charset="-120"/>
-              </a:rPr>
-              <a:t>Kirim follow-up ke [nama] soal [topik] yang belum direspons sejak [tanggal]. Tone: sopan, gentle reminder. Jangan terkesan mendesak.</a:t>
-            </a:r>
-            <a:endParaRPr lang="en-US" sz="1150" dirty="0"/>
-          </a:p>
-        </p:txBody>
-      </p:sp>
-      <p:sp>
-        <p:nvSpPr>
-          <p:cNvPr id="26" name="Shape 24"/>
-          <p:cNvSpPr/>
-          <p:nvPr/>
-        </p:nvSpPr>
-        <p:spPr>
-          <a:xfrm>
-            <a:off x="6345936" y="4389120"/>
-            <a:ext cx="5440680" cy="2103120"/>
-          </a:xfrm>
-          <a:prstGeom prst="roundRect">
-            <a:avLst>
-              <a:gd name="adj" fmla="val 5217"/>
+              <a:gd name="adj" fmla="val 7937"/>
             </a:avLst>
           </a:prstGeom>
           <a:solidFill>
@@ -3704,36 +3621,34 @@
       </p:sp>
       <p:sp>
         <p:nvSpPr>
-          <p:cNvPr id="27" name="Shape 25"/>
-          <p:cNvSpPr/>
-          <p:nvPr/>
-        </p:nvSpPr>
-        <p:spPr>
-          <a:xfrm>
-            <a:off x="6510528" y="4535424"/>
-            <a:ext cx="1417320" cy="292608"/>
-          </a:xfrm>
-          <a:prstGeom prst="roundRect">
-            <a:avLst>
-              <a:gd name="adj" fmla="val 21875"/>
-            </a:avLst>
-          </a:prstGeom>
-          <a:solidFill>
-            <a:srgbClr val="F4F6FB"/>
-          </a:solidFill>
-          <a:ln/>
-        </p:spPr>
-      </p:sp>
-      <p:sp>
-        <p:nvSpPr>
-          <p:cNvPr id="28" name="Text 26"/>
-          <p:cNvSpPr/>
-          <p:nvPr/>
-        </p:nvSpPr>
-        <p:spPr>
-          <a:xfrm>
-            <a:off x="6510528" y="4535424"/>
-            <a:ext cx="1417320" cy="292608"/>
+          <p:cNvPr id="24" name="Shape 22"/>
+          <p:cNvSpPr/>
+          <p:nvPr/>
+        </p:nvSpPr>
+        <p:spPr>
+          <a:xfrm>
+            <a:off x="6388456" y="3630056"/>
+            <a:ext cx="365760" cy="365760"/>
+          </a:xfrm>
+          <a:prstGeom prst="ellipse">
+            <a:avLst/>
+          </a:prstGeom>
+          <a:solidFill>
+            <a:srgbClr val="6849F6"/>
+          </a:solidFill>
+          <a:ln/>
+        </p:spPr>
+      </p:sp>
+      <p:sp>
+        <p:nvSpPr>
+          <p:cNvPr id="25" name="Text 23"/>
+          <p:cNvSpPr/>
+          <p:nvPr/>
+        </p:nvSpPr>
+        <p:spPr>
+          <a:xfrm>
+            <a:off x="6388456" y="3630056"/>
+            <a:ext cx="365760" cy="365760"/>
           </a:xfrm>
           <a:prstGeom prst="rect">
             <a:avLst/>
@@ -3749,30 +3664,30 @@
               <a:buNone/>
             </a:pPr>
             <a:r>
-              <a:rPr lang="en-US" sz="950" b="1" dirty="0">
-                <a:solidFill>
-                  <a:srgbClr val="6B7280"/>
-                </a:solidFill>
-                <a:latin typeface="Arial" pitchFamily="34" charset="0"/>
-                <a:ea typeface="Arial" pitchFamily="34" charset="-122"/>
-                <a:cs typeface="Arial" pitchFamily="34" charset="-120"/>
-              </a:rPr>
-              <a:t>RUTIN</a:t>
-            </a:r>
-            <a:endParaRPr lang="en-US" sz="950" dirty="0"/>
-          </a:p>
-        </p:txBody>
-      </p:sp>
-      <p:sp>
-        <p:nvSpPr>
-          <p:cNvPr id="29" name="Text 27"/>
-          <p:cNvSpPr/>
-          <p:nvPr/>
-        </p:nvSpPr>
-        <p:spPr>
-          <a:xfrm>
-            <a:off x="8037576" y="4544568"/>
-            <a:ext cx="3566160" cy="292608"/>
+              <a:rPr lang="en-US" sz="1400" b="1" dirty="0">
+                <a:solidFill>
+                  <a:srgbClr val="FFFFFF"/>
+                </a:solidFill>
+                <a:latin typeface="Helvetica" pitchFamily="34" charset="0"/>
+                <a:ea typeface="Helvetica" pitchFamily="34" charset="-122"/>
+                <a:cs typeface="Helvetica" pitchFamily="34" charset="-120"/>
+              </a:rPr>
+              <a:t>4</a:t>
+            </a:r>
+            <a:endParaRPr lang="en-US" sz="1400" dirty="0"/>
+          </a:p>
+        </p:txBody>
+      </p:sp>
+      <p:sp>
+        <p:nvSpPr>
+          <p:cNvPr id="26" name="Text 24"/>
+          <p:cNvSpPr/>
+          <p:nvPr/>
+        </p:nvSpPr>
+        <p:spPr>
+          <a:xfrm>
+            <a:off x="6882232" y="3602624"/>
+            <a:ext cx="4577944" cy="310896"/>
           </a:xfrm>
           <a:prstGeom prst="rect">
             <a:avLst/>
@@ -3788,57 +3703,30 @@
               <a:buNone/>
             </a:pPr>
             <a:r>
-              <a:rPr lang="en-US" sz="1250" b="1" dirty="0">
+              <a:rPr lang="en-US" sz="1300" b="1" dirty="0">
                 <a:solidFill>
                   <a:srgbClr val="0D1321"/>
                 </a:solidFill>
-                <a:latin typeface="Arial" pitchFamily="34" charset="0"/>
-                <a:ea typeface="Arial" pitchFamily="34" charset="-122"/>
-                <a:cs typeface="Arial" pitchFamily="34" charset="-120"/>
+                <a:latin typeface="Helvetica" pitchFamily="34" charset="0"/>
+                <a:ea typeface="Helvetica" pitchFamily="34" charset="-122"/>
+                <a:cs typeface="Helvetica" pitchFamily="34" charset="-120"/>
               </a:rPr>
               <a:t>Konfirmasi &amp; Informasi</a:t>
             </a:r>
-            <a:endParaRPr lang="en-US" sz="1250" dirty="0"/>
-          </a:p>
-        </p:txBody>
-      </p:sp>
-      <p:sp>
-        <p:nvSpPr>
-          <p:cNvPr id="30" name="Shape 28"/>
-          <p:cNvSpPr/>
-          <p:nvPr/>
-        </p:nvSpPr>
-        <p:spPr>
-          <a:xfrm>
-            <a:off x="6510528" y="4937760"/>
-            <a:ext cx="5111496" cy="1417320"/>
-          </a:xfrm>
-          <a:prstGeom prst="roundRect">
-            <a:avLst>
-              <a:gd name="adj" fmla="val 5161"/>
-            </a:avLst>
-          </a:prstGeom>
-          <a:solidFill>
-            <a:srgbClr val="0D1321"/>
-          </a:solidFill>
-          <a:ln w="9525">
-            <a:solidFill>
-              <a:srgbClr val="6849F6"/>
-            </a:solidFill>
-            <a:prstDash val="solid"/>
-          </a:ln>
-        </p:spPr>
-      </p:sp>
-      <p:sp>
-        <p:nvSpPr>
-          <p:cNvPr id="31" name="Text 29"/>
-          <p:cNvSpPr/>
-          <p:nvPr/>
-        </p:nvSpPr>
-        <p:spPr>
-          <a:xfrm>
-            <a:off x="6665976" y="5029200"/>
-            <a:ext cx="4846320" cy="1234440"/>
+            <a:endParaRPr lang="en-US" sz="1300" dirty="0"/>
+          </a:p>
+        </p:txBody>
+      </p:sp>
+      <p:sp>
+        <p:nvSpPr>
+          <p:cNvPr id="27" name="Text 25"/>
+          <p:cNvSpPr/>
+          <p:nvPr/>
+        </p:nvSpPr>
+        <p:spPr>
+          <a:xfrm>
+            <a:off x="6388456" y="4014104"/>
+            <a:ext cx="5071720" cy="402224"/>
           </a:xfrm>
           <a:prstGeom prst="rect">
             <a:avLst/>
@@ -3852,22 +3740,22 @@
           <a:p>
             <a:pPr indent="0" marL="0">
               <a:lnSpc>
-                <a:spcPct val="130000"/>
+                <a:spcPct val="122000"/>
               </a:lnSpc>
               <a:buNone/>
             </a:pPr>
             <a:r>
-              <a:rPr lang="en-US" sz="1150" i="1" dirty="0">
-                <a:solidFill>
-                  <a:srgbClr val="FFFFFF"/>
-                </a:solidFill>
-                <a:latin typeface="Arial" pitchFamily="34" charset="0"/>
-                <a:ea typeface="Arial" pitchFamily="34" charset="-122"/>
-                <a:cs typeface="Arial" pitchFamily="34" charset="-120"/>
+              <a:rPr lang="en-US" sz="1100" dirty="0">
+                <a:solidFill>
+                  <a:srgbClr val="23283A"/>
+                </a:solidFill>
+                <a:latin typeface="Helvetica" pitchFamily="34" charset="0"/>
+                <a:ea typeface="Helvetica" pitchFamily="34" charset="-122"/>
+                <a:cs typeface="Helvetica" pitchFamily="34" charset="-120"/>
               </a:rPr>
               <a:t>Tulis konfirmasi ke [nama] bahwa [detail pesanan/meeting/keputusan] sudah diterima. Sertakan ringkasan poin penting. Singkat, maks 60 kata.</a:t>
             </a:r>
-            <a:endParaRPr lang="en-US" sz="1150" dirty="0"/>
+            <a:endParaRPr lang="en-US" sz="1100" dirty="0"/>
           </a:p>
         </p:txBody>
       </p:sp>
@@ -3882,6 +3770,13 @@
 <file path=ppt/slides/slide4.xml><?xml version="1.0" encoding="utf-8"?>
 <p:sld xmlns:a="http://schemas.openxmlformats.org/drawingml/2006/main" xmlns:r="http://schemas.openxmlformats.org/officeDocument/2006/relationships" xmlns:p="http://schemas.openxmlformats.org/presentationml/2006/main">
   <p:cSld name="Slide 4">
+    <p:bg>
+      <p:bgPr>
+        <a:solidFill>
+          <a:srgbClr val="FFFFFF"/>
+        </a:solidFill>
+      </p:bgPr>
+    </p:bg>
     <p:spTree>
       <p:nvGrpSpPr>
         <p:cNvPr id="1" name=""/>
@@ -3965,9 +3860,9 @@
                 <a:solidFill>
                   <a:srgbClr val="FFFFFF"/>
                 </a:solidFill>
-                <a:latin typeface="Arial" pitchFamily="34" charset="0"/>
-                <a:ea typeface="Arial" pitchFamily="34" charset="-122"/>
-                <a:cs typeface="Arial" pitchFamily="34" charset="-120"/>
+                <a:latin typeface="Helvetica" pitchFamily="34" charset="0"/>
+                <a:ea typeface="Helvetica" pitchFamily="34" charset="-122"/>
+                <a:cs typeface="Helvetica" pitchFamily="34" charset="-120"/>
               </a:rPr>
               <a:t>belajar</a:t>
             </a:r>
@@ -3979,9 +3874,9 @@
                 <a:solidFill>
                   <a:srgbClr val="8B7CF6"/>
                 </a:solidFill>
-                <a:latin typeface="Arial" pitchFamily="34" charset="0"/>
-                <a:ea typeface="Arial" pitchFamily="34" charset="-122"/>
-                <a:cs typeface="Arial" pitchFamily="34" charset="-120"/>
+                <a:latin typeface="Helvetica" pitchFamily="34" charset="0"/>
+                <a:ea typeface="Helvetica" pitchFamily="34" charset="-122"/>
+                <a:cs typeface="Helvetica" pitchFamily="34" charset="-120"/>
               </a:rPr>
               <a:t>claude</a:t>
             </a:r>
@@ -4018,9 +3913,9 @@
                 <a:solidFill>
                   <a:srgbClr val="9AA2B4"/>
                 </a:solidFill>
-                <a:latin typeface="Arial" pitchFamily="34" charset="0"/>
-                <a:ea typeface="Arial" pitchFamily="34" charset="-122"/>
-                <a:cs typeface="Arial" pitchFamily="34" charset="-120"/>
+                <a:latin typeface="Helvetica" pitchFamily="34" charset="0"/>
+                <a:ea typeface="Helvetica" pitchFamily="34" charset="-122"/>
+                <a:cs typeface="Helvetica" pitchFamily="34" charset="-120"/>
               </a:rPr>
               <a:t>Modul 03 — Gmail + Claude</a:t>
             </a:r>
@@ -4036,8 +3931,8 @@
         </p:nvSpPr>
         <p:spPr>
           <a:xfrm>
-            <a:off x="502920" y="1097280"/>
-            <a:ext cx="11155680" cy="548640"/>
+            <a:off x="548640" y="1188720"/>
+            <a:ext cx="11064240" cy="502920"/>
           </a:xfrm>
           <a:prstGeom prst="rect">
             <a:avLst/>
@@ -4057,9 +3952,9 @@
                 <a:solidFill>
                   <a:srgbClr val="0D1321"/>
                 </a:solidFill>
-                <a:latin typeface="Arial" pitchFamily="34" charset="0"/>
-                <a:ea typeface="Arial" pitchFamily="34" charset="-122"/>
-                <a:cs typeface="Arial" pitchFamily="34" charset="-120"/>
+                <a:latin typeface="Helvetica" pitchFamily="34" charset="0"/>
+                <a:ea typeface="Helvetica" pitchFamily="34" charset="-122"/>
+                <a:cs typeface="Helvetica" pitchFamily="34" charset="-120"/>
               </a:rPr>
               <a:t>Checklist &amp; Latihan</a:t>
             </a:r>
@@ -4075,8 +3970,8 @@
         </p:nvSpPr>
         <p:spPr>
           <a:xfrm>
-            <a:off x="502920" y="1737360"/>
-            <a:ext cx="11155680" cy="256032"/>
+            <a:off x="548640" y="1783080"/>
+            <a:ext cx="11094415" cy="274320"/>
           </a:xfrm>
           <a:prstGeom prst="rect">
             <a:avLst/>
@@ -4092,17 +3987,17 @@
               <a:buNone/>
             </a:pPr>
             <a:r>
-              <a:rPr lang="en-US" sz="1200" b="1" spc="30" kern="0" dirty="0">
+              <a:rPr lang="en-US" sz="1250" b="1" spc="40" kern="0" dirty="0">
                 <a:solidFill>
                   <a:srgbClr val="4B36C7"/>
                 </a:solidFill>
-                <a:latin typeface="Arial" pitchFamily="34" charset="0"/>
-                <a:ea typeface="Arial" pitchFamily="34" charset="-122"/>
-                <a:cs typeface="Arial" pitchFamily="34" charset="-120"/>
+                <a:latin typeface="Helvetica" pitchFamily="34" charset="0"/>
+                <a:ea typeface="Helvetica" pitchFamily="34" charset="-122"/>
+                <a:cs typeface="Helvetica" pitchFamily="34" charset="-120"/>
               </a:rPr>
               <a:t>SEBELUM KIRIM + LATIHAN HARI INI</a:t>
             </a:r>
-            <a:endParaRPr lang="en-US" sz="1200" dirty="0"/>
+            <a:endParaRPr lang="en-US" sz="1250" dirty="0"/>
           </a:p>
         </p:txBody>
       </p:sp>
@@ -4114,12 +4009,220 @@
         </p:nvSpPr>
         <p:spPr>
           <a:xfrm>
-            <a:off x="502920" y="2057400"/>
-            <a:ext cx="11155680" cy="1719072"/>
+            <a:off x="548640" y="2112264"/>
+            <a:ext cx="5410048" cy="2206447"/>
           </a:xfrm>
           <a:prstGeom prst="roundRect">
             <a:avLst>
-              <a:gd name="adj" fmla="val 6383"/>
+              <a:gd name="adj" fmla="val 4144"/>
+            </a:avLst>
+          </a:prstGeom>
+          <a:solidFill>
+            <a:srgbClr val="F4F6FB"/>
+          </a:solidFill>
+          <a:ln w="12700">
+            <a:solidFill>
+              <a:srgbClr val="D6DCEB"/>
+            </a:solidFill>
+            <a:prstDash val="solid"/>
+          </a:ln>
+        </p:spPr>
+      </p:sp>
+      <p:sp>
+        <p:nvSpPr>
+          <p:cNvPr id="9" name="Text 7"/>
+          <p:cNvSpPr/>
+          <p:nvPr/>
+        </p:nvSpPr>
+        <p:spPr>
+          <a:xfrm>
+            <a:off x="749808" y="2313432"/>
+            <a:ext cx="5007712" cy="274320"/>
+          </a:xfrm>
+          <a:prstGeom prst="rect">
+            <a:avLst/>
+          </a:prstGeom>
+          <a:noFill/>
+          <a:ln/>
+        </p:spPr>
+        <p:txBody>
+          <a:bodyPr wrap="square" lIns="0" tIns="0" rIns="0" bIns="0" rtlCol="0" anchor="ctr"/>
+          <a:lstStyle/>
+          <a:p>
+            <a:pPr indent="0" marL="0">
+              <a:buNone/>
+            </a:pPr>
+            <a:r>
+              <a:rPr lang="en-US" sz="1200" b="1" spc="30" kern="0" dirty="0">
+                <a:solidFill>
+                  <a:srgbClr val="6B7280"/>
+                </a:solidFill>
+                <a:latin typeface="Helvetica" pitchFamily="34" charset="0"/>
+                <a:ea typeface="Helvetica" pitchFamily="34" charset="-122"/>
+                <a:cs typeface="Helvetica" pitchFamily="34" charset="-120"/>
+              </a:rPr>
+              <a:t>CHECKLIST SEBELUM KIRIM</a:t>
+            </a:r>
+            <a:endParaRPr lang="en-US" sz="1200" dirty="0"/>
+          </a:p>
+        </p:txBody>
+      </p:sp>
+      <p:sp>
+        <p:nvSpPr>
+          <p:cNvPr id="10" name="Text 8"/>
+          <p:cNvSpPr/>
+          <p:nvPr/>
+        </p:nvSpPr>
+        <p:spPr>
+          <a:xfrm>
+            <a:off x="749808" y="2660904"/>
+            <a:ext cx="5007712" cy="1456639"/>
+          </a:xfrm>
+          <a:prstGeom prst="rect">
+            <a:avLst/>
+          </a:prstGeom>
+          <a:noFill/>
+          <a:ln/>
+        </p:spPr>
+        <p:txBody>
+          <a:bodyPr wrap="square" lIns="0" tIns="0" rIns="0" bIns="0" rtlCol="0" anchor="t"/>
+          <a:lstStyle/>
+          <a:p>
+            <a:pPr indent="0" marL="0">
+              <a:lnSpc>
+                <a:spcPct val="135000"/>
+              </a:lnSpc>
+              <a:buNone/>
+            </a:pPr>
+            <a:r>
+              <a:rPr lang="en-US" sz="1200" dirty="0">
+                <a:solidFill>
+                  <a:srgbClr val="23283A"/>
+                </a:solidFill>
+                <a:latin typeface="Helvetica" pitchFamily="34" charset="0"/>
+                <a:ea typeface="Helvetica" pitchFamily="34" charset="-122"/>
+                <a:cs typeface="Helvetica" pitchFamily="34" charset="-120"/>
+              </a:rPr>
+              <a:t>•  Nama penerima benar (bukan placeholder [nama])</a:t>
+            </a:r>
+            <a:endParaRPr lang="en-US" sz="1200" dirty="0"/>
+          </a:p>
+          <a:p>
+            <a:pPr indent="0" marL="0">
+              <a:lnSpc>
+                <a:spcPct val="135000"/>
+              </a:lnSpc>
+              <a:buNone/>
+            </a:pPr>
+            <a:r>
+              <a:rPr lang="en-US" sz="1200" dirty="0">
+                <a:solidFill>
+                  <a:srgbClr val="23283A"/>
+                </a:solidFill>
+                <a:latin typeface="Helvetica" pitchFamily="34" charset="0"/>
+                <a:ea typeface="Helvetica" pitchFamily="34" charset="-122"/>
+                <a:cs typeface="Helvetica" pitchFamily="34" charset="-120"/>
+              </a:rPr>
+              <a:t>•  Isi email akurat, bukan halusinasi Claude</a:t>
+            </a:r>
+            <a:endParaRPr lang="en-US" sz="1200" dirty="0"/>
+          </a:p>
+          <a:p>
+            <a:pPr indent="0" marL="0">
+              <a:lnSpc>
+                <a:spcPct val="135000"/>
+              </a:lnSpc>
+              <a:buNone/>
+            </a:pPr>
+            <a:r>
+              <a:rPr lang="en-US" sz="1200" dirty="0">
+                <a:solidFill>
+                  <a:srgbClr val="23283A"/>
+                </a:solidFill>
+                <a:latin typeface="Helvetica" pitchFamily="34" charset="0"/>
+                <a:ea typeface="Helvetica" pitchFamily="34" charset="-122"/>
+                <a:cs typeface="Helvetica" pitchFamily="34" charset="-120"/>
+              </a:rPr>
+              <a:t>•  Ada CTA yang jelas jika diperlukan</a:t>
+            </a:r>
+            <a:endParaRPr lang="en-US" sz="1200" dirty="0"/>
+          </a:p>
+          <a:p>
+            <a:pPr indent="0" marL="0">
+              <a:lnSpc>
+                <a:spcPct val="135000"/>
+              </a:lnSpc>
+              <a:buNone/>
+            </a:pPr>
+            <a:r>
+              <a:rPr lang="en-US" sz="1200" dirty="0">
+                <a:solidFill>
+                  <a:srgbClr val="23283A"/>
+                </a:solidFill>
+                <a:latin typeface="Helvetica" pitchFamily="34" charset="0"/>
+                <a:ea typeface="Helvetica" pitchFamily="34" charset="-122"/>
+                <a:cs typeface="Helvetica" pitchFamily="34" charset="-120"/>
+              </a:rPr>
+              <a:t>•  Tone sudah sesuai: formal / santai / tegas?</a:t>
+            </a:r>
+            <a:endParaRPr lang="en-US" sz="1200" dirty="0"/>
+          </a:p>
+          <a:p>
+            <a:pPr indent="0" marL="0">
+              <a:lnSpc>
+                <a:spcPct val="135000"/>
+              </a:lnSpc>
+              <a:buNone/>
+            </a:pPr>
+            <a:r>
+              <a:rPr lang="en-US" sz="1200" dirty="0">
+                <a:solidFill>
+                  <a:srgbClr val="23283A"/>
+                </a:solidFill>
+                <a:latin typeface="Helvetica" pitchFamily="34" charset="0"/>
+                <a:ea typeface="Helvetica" pitchFamily="34" charset="-122"/>
+                <a:cs typeface="Helvetica" pitchFamily="34" charset="-120"/>
+              </a:rPr>
+              <a:t>•  Tidak ada info sensitif yang ikut di-paste ke Claude</a:t>
+            </a:r>
+            <a:endParaRPr lang="en-US" sz="1200" dirty="0"/>
+          </a:p>
+          <a:p>
+            <a:pPr indent="0" marL="0">
+              <a:lnSpc>
+                <a:spcPct val="135000"/>
+              </a:lnSpc>
+              <a:buNone/>
+            </a:pPr>
+            <a:r>
+              <a:rPr lang="en-US" sz="1200" dirty="0">
+                <a:solidFill>
+                  <a:srgbClr val="23283A"/>
+                </a:solidFill>
+                <a:latin typeface="Helvetica" pitchFamily="34" charset="0"/>
+                <a:ea typeface="Helvetica" pitchFamily="34" charset="-122"/>
+                <a:cs typeface="Helvetica" pitchFamily="34" charset="-120"/>
+              </a:rPr>
+              <a:t>•  Panjang sudah sesuai, tidak bertele-tele</a:t>
+            </a:r>
+            <a:endParaRPr lang="en-US" sz="1200" dirty="0"/>
+          </a:p>
+        </p:txBody>
+      </p:sp>
+      <p:sp>
+        <p:nvSpPr>
+          <p:cNvPr id="11" name="Shape 9"/>
+          <p:cNvSpPr/>
+          <p:nvPr/>
+        </p:nvSpPr>
+        <p:spPr>
+          <a:xfrm>
+            <a:off x="6233008" y="2112264"/>
+            <a:ext cx="5410048" cy="2206447"/>
+          </a:xfrm>
+          <a:prstGeom prst="roundRect">
+            <a:avLst>
+              <a:gd name="adj" fmla="val 4144"/>
             </a:avLst>
           </a:prstGeom>
           <a:solidFill>
@@ -4135,14 +4238,14 @@
       </p:sp>
       <p:sp>
         <p:nvSpPr>
-          <p:cNvPr id="9" name="Text 7"/>
-          <p:cNvSpPr/>
-          <p:nvPr/>
-        </p:nvSpPr>
-        <p:spPr>
-          <a:xfrm>
-            <a:off x="749808" y="2176272"/>
-            <a:ext cx="5486400" cy="256032"/>
+          <p:cNvPr id="12" name="Text 10"/>
+          <p:cNvSpPr/>
+          <p:nvPr/>
+        </p:nvSpPr>
+        <p:spPr>
+          <a:xfrm>
+            <a:off x="6434176" y="2313432"/>
+            <a:ext cx="5007712" cy="274320"/>
           </a:xfrm>
           <a:prstGeom prst="rect">
             <a:avLst/>
@@ -4158,718 +4261,76 @@
               <a:buNone/>
             </a:pPr>
             <a:r>
-              <a:rPr lang="en-US" sz="1150" b="1" dirty="0">
+              <a:rPr lang="en-US" sz="1200" b="1" spc="30" kern="0" dirty="0">
                 <a:solidFill>
                   <a:srgbClr val="4B36C7"/>
                 </a:solidFill>
-                <a:latin typeface="Arial" pitchFamily="34" charset="0"/>
-                <a:ea typeface="Arial" pitchFamily="34" charset="-122"/>
-                <a:cs typeface="Arial" pitchFamily="34" charset="-120"/>
-              </a:rPr>
-              <a:t>CHECKLIST SEBELUM KIRIM</a:t>
-            </a:r>
-            <a:endParaRPr lang="en-US" sz="1150" dirty="0"/>
-          </a:p>
-        </p:txBody>
-      </p:sp>
-      <p:sp>
-        <p:nvSpPr>
-          <p:cNvPr id="10" name="Shape 8"/>
-          <p:cNvSpPr/>
-          <p:nvPr/>
-        </p:nvSpPr>
-        <p:spPr>
-          <a:xfrm>
-            <a:off x="749808" y="2523744"/>
-            <a:ext cx="182880" cy="182880"/>
-          </a:xfrm>
-          <a:prstGeom prst="rect">
-            <a:avLst/>
-          </a:prstGeom>
-          <a:solidFill>
-            <a:srgbClr val="1A7A44"/>
-          </a:solidFill>
-          <a:ln w="12700">
-            <a:solidFill>
-              <a:srgbClr val="1A7A44"/>
-            </a:solidFill>
-            <a:prstDash val="solid"/>
-          </a:ln>
-        </p:spPr>
-      </p:sp>
-      <p:sp>
-        <p:nvSpPr>
-          <p:cNvPr id="11" name="Text 9"/>
-          <p:cNvSpPr/>
-          <p:nvPr/>
-        </p:nvSpPr>
-        <p:spPr>
-          <a:xfrm>
-            <a:off x="749808" y="2505456"/>
-            <a:ext cx="182880" cy="182880"/>
-          </a:xfrm>
-          <a:prstGeom prst="rect">
-            <a:avLst/>
-          </a:prstGeom>
-          <a:noFill/>
-          <a:ln/>
-        </p:spPr>
-        <p:txBody>
-          <a:bodyPr wrap="square" lIns="0" tIns="0" rIns="0" bIns="0" rtlCol="0" anchor="ctr"/>
-          <a:lstStyle/>
-          <a:p>
-            <a:pPr algn="ctr" indent="0" marL="0">
-              <a:buNone/>
-            </a:pPr>
-            <a:r>
-              <a:rPr lang="en-US" sz="1000" b="1" dirty="0">
-                <a:solidFill>
-                  <a:srgbClr val="FFFFFF"/>
-                </a:solidFill>
-                <a:latin typeface="Arial" pitchFamily="34" charset="0"/>
-                <a:ea typeface="Arial" pitchFamily="34" charset="-122"/>
-                <a:cs typeface="Arial" pitchFamily="34" charset="-120"/>
-              </a:rPr>
-              <a:t>v</a:t>
-            </a:r>
-            <a:endParaRPr lang="en-US" sz="1000" dirty="0"/>
-          </a:p>
-        </p:txBody>
-      </p:sp>
-      <p:sp>
-        <p:nvSpPr>
-          <p:cNvPr id="12" name="Text 10"/>
-          <p:cNvSpPr/>
-          <p:nvPr/>
-        </p:nvSpPr>
-        <p:spPr>
-          <a:xfrm>
-            <a:off x="1005840" y="2478024"/>
-            <a:ext cx="5074920" cy="310896"/>
-          </a:xfrm>
-          <a:prstGeom prst="rect">
-            <a:avLst/>
-          </a:prstGeom>
-          <a:noFill/>
-          <a:ln/>
-        </p:spPr>
-        <p:txBody>
-          <a:bodyPr wrap="square" lIns="0" tIns="0" rIns="0" bIns="0" rtlCol="0" anchor="ctr"/>
-          <a:lstStyle/>
-          <a:p>
-            <a:pPr indent="0" marL="0">
-              <a:buNone/>
-            </a:pPr>
-            <a:r>
-              <a:rPr lang="en-US" sz="1100" dirty="0">
+                <a:latin typeface="Helvetica" pitchFamily="34" charset="0"/>
+                <a:ea typeface="Helvetica" pitchFamily="34" charset="-122"/>
+                <a:cs typeface="Helvetica" pitchFamily="34" charset="-120"/>
+              </a:rPr>
+              <a:t>BONUS</a:t>
+            </a:r>
+            <a:endParaRPr lang="en-US" sz="1200" dirty="0"/>
+          </a:p>
+        </p:txBody>
+      </p:sp>
+      <p:sp>
+        <p:nvSpPr>
+          <p:cNvPr id="13" name="Text 11"/>
+          <p:cNvSpPr/>
+          <p:nvPr/>
+        </p:nvSpPr>
+        <p:spPr>
+          <a:xfrm>
+            <a:off x="6434176" y="2660904"/>
+            <a:ext cx="5007712" cy="1456639"/>
+          </a:xfrm>
+          <a:prstGeom prst="rect">
+            <a:avLst/>
+          </a:prstGeom>
+          <a:noFill/>
+          <a:ln/>
+        </p:spPr>
+        <p:txBody>
+          <a:bodyPr wrap="square" lIns="0" tIns="0" rIns="0" bIns="0" rtlCol="0" anchor="t"/>
+          <a:lstStyle/>
+          <a:p>
+            <a:pPr indent="0" marL="0">
+              <a:lnSpc>
+                <a:spcPct val="135000"/>
+              </a:lnSpc>
+              <a:buNone/>
+            </a:pPr>
+            <a:r>
+              <a:rPr lang="en-US" sz="1200" dirty="0">
                 <a:solidFill>
                   <a:srgbClr val="23283A"/>
                 </a:solidFill>
-                <a:latin typeface="Arial" pitchFamily="34" charset="0"/>
-                <a:ea typeface="Arial" pitchFamily="34" charset="-122"/>
-                <a:cs typeface="Arial" pitchFamily="34" charset="-120"/>
-              </a:rPr>
-              <a:t>Nama penerima benar (bukan placeholder [nama])</a:t>
-            </a:r>
-            <a:endParaRPr lang="en-US" sz="1100" dirty="0"/>
-          </a:p>
-        </p:txBody>
-      </p:sp>
-      <p:sp>
-        <p:nvSpPr>
-          <p:cNvPr id="13" name="Shape 11"/>
-          <p:cNvSpPr/>
-          <p:nvPr/>
-        </p:nvSpPr>
-        <p:spPr>
-          <a:xfrm>
-            <a:off x="6236208" y="2523744"/>
-            <a:ext cx="182880" cy="182880"/>
-          </a:xfrm>
-          <a:prstGeom prst="rect">
-            <a:avLst/>
-          </a:prstGeom>
-          <a:solidFill>
-            <a:srgbClr val="1A7A44"/>
-          </a:solidFill>
-          <a:ln w="12700">
-            <a:solidFill>
-              <a:srgbClr val="1A7A44"/>
-            </a:solidFill>
-            <a:prstDash val="solid"/>
-          </a:ln>
-        </p:spPr>
-      </p:sp>
-      <p:sp>
-        <p:nvSpPr>
-          <p:cNvPr id="14" name="Text 12"/>
-          <p:cNvSpPr/>
-          <p:nvPr/>
-        </p:nvSpPr>
-        <p:spPr>
-          <a:xfrm>
-            <a:off x="6236208" y="2505456"/>
-            <a:ext cx="182880" cy="182880"/>
-          </a:xfrm>
-          <a:prstGeom prst="rect">
-            <a:avLst/>
-          </a:prstGeom>
-          <a:noFill/>
-          <a:ln/>
-        </p:spPr>
-        <p:txBody>
-          <a:bodyPr wrap="square" lIns="0" tIns="0" rIns="0" bIns="0" rtlCol="0" anchor="ctr"/>
-          <a:lstStyle/>
-          <a:p>
-            <a:pPr algn="ctr" indent="0" marL="0">
-              <a:buNone/>
-            </a:pPr>
-            <a:r>
-              <a:rPr lang="en-US" sz="1000" b="1" dirty="0">
-                <a:solidFill>
-                  <a:srgbClr val="FFFFFF"/>
-                </a:solidFill>
-                <a:latin typeface="Arial" pitchFamily="34" charset="0"/>
-                <a:ea typeface="Arial" pitchFamily="34" charset="-122"/>
-                <a:cs typeface="Arial" pitchFamily="34" charset="-120"/>
-              </a:rPr>
-              <a:t>v</a:t>
-            </a:r>
-            <a:endParaRPr lang="en-US" sz="1000" dirty="0"/>
-          </a:p>
-        </p:txBody>
-      </p:sp>
-      <p:sp>
-        <p:nvSpPr>
-          <p:cNvPr id="15" name="Text 13"/>
-          <p:cNvSpPr/>
-          <p:nvPr/>
-        </p:nvSpPr>
-        <p:spPr>
-          <a:xfrm>
-            <a:off x="6492240" y="2478024"/>
-            <a:ext cx="5074920" cy="310896"/>
-          </a:xfrm>
-          <a:prstGeom prst="rect">
-            <a:avLst/>
-          </a:prstGeom>
-          <a:noFill/>
-          <a:ln/>
-        </p:spPr>
-        <p:txBody>
-          <a:bodyPr wrap="square" lIns="0" tIns="0" rIns="0" bIns="0" rtlCol="0" anchor="ctr"/>
-          <a:lstStyle/>
-          <a:p>
-            <a:pPr indent="0" marL="0">
-              <a:buNone/>
-            </a:pPr>
-            <a:r>
-              <a:rPr lang="en-US" sz="1100" dirty="0">
-                <a:solidFill>
-                  <a:srgbClr val="23283A"/>
-                </a:solidFill>
-                <a:latin typeface="Arial" pitchFamily="34" charset="0"/>
-                <a:ea typeface="Arial" pitchFamily="34" charset="-122"/>
-                <a:cs typeface="Arial" pitchFamily="34" charset="-120"/>
-              </a:rPr>
-              <a:t>Tone sudah sesuai: formal / santai / tegas?</a:t>
-            </a:r>
-            <a:endParaRPr lang="en-US" sz="1100" dirty="0"/>
-          </a:p>
-        </p:txBody>
-      </p:sp>
-      <p:sp>
-        <p:nvSpPr>
-          <p:cNvPr id="16" name="Shape 14"/>
-          <p:cNvSpPr/>
-          <p:nvPr/>
-        </p:nvSpPr>
-        <p:spPr>
-          <a:xfrm>
-            <a:off x="749808" y="2944368"/>
-            <a:ext cx="182880" cy="182880"/>
-          </a:xfrm>
-          <a:prstGeom prst="rect">
-            <a:avLst/>
-          </a:prstGeom>
-          <a:solidFill>
-            <a:srgbClr val="1A7A44"/>
-          </a:solidFill>
-          <a:ln w="12700">
-            <a:solidFill>
-              <a:srgbClr val="1A7A44"/>
-            </a:solidFill>
-            <a:prstDash val="solid"/>
-          </a:ln>
-        </p:spPr>
-      </p:sp>
-      <p:sp>
-        <p:nvSpPr>
-          <p:cNvPr id="17" name="Text 15"/>
-          <p:cNvSpPr/>
-          <p:nvPr/>
-        </p:nvSpPr>
-        <p:spPr>
-          <a:xfrm>
-            <a:off x="749808" y="2926080"/>
-            <a:ext cx="182880" cy="182880"/>
-          </a:xfrm>
-          <a:prstGeom prst="rect">
-            <a:avLst/>
-          </a:prstGeom>
-          <a:noFill/>
-          <a:ln/>
-        </p:spPr>
-        <p:txBody>
-          <a:bodyPr wrap="square" lIns="0" tIns="0" rIns="0" bIns="0" rtlCol="0" anchor="ctr"/>
-          <a:lstStyle/>
-          <a:p>
-            <a:pPr algn="ctr" indent="0" marL="0">
-              <a:buNone/>
-            </a:pPr>
-            <a:r>
-              <a:rPr lang="en-US" sz="1000" b="1" dirty="0">
-                <a:solidFill>
-                  <a:srgbClr val="FFFFFF"/>
-                </a:solidFill>
-                <a:latin typeface="Arial" pitchFamily="34" charset="0"/>
-                <a:ea typeface="Arial" pitchFamily="34" charset="-122"/>
-                <a:cs typeface="Arial" pitchFamily="34" charset="-120"/>
-              </a:rPr>
-              <a:t>v</a:t>
-            </a:r>
-            <a:endParaRPr lang="en-US" sz="1000" dirty="0"/>
-          </a:p>
-        </p:txBody>
-      </p:sp>
-      <p:sp>
-        <p:nvSpPr>
-          <p:cNvPr id="18" name="Text 16"/>
-          <p:cNvSpPr/>
-          <p:nvPr/>
-        </p:nvSpPr>
-        <p:spPr>
-          <a:xfrm>
-            <a:off x="1005840" y="2898648"/>
-            <a:ext cx="5074920" cy="310896"/>
-          </a:xfrm>
-          <a:prstGeom prst="rect">
-            <a:avLst/>
-          </a:prstGeom>
-          <a:noFill/>
-          <a:ln/>
-        </p:spPr>
-        <p:txBody>
-          <a:bodyPr wrap="square" lIns="0" tIns="0" rIns="0" bIns="0" rtlCol="0" anchor="ctr"/>
-          <a:lstStyle/>
-          <a:p>
-            <a:pPr indent="0" marL="0">
-              <a:buNone/>
-            </a:pPr>
-            <a:r>
-              <a:rPr lang="en-US" sz="1100" dirty="0">
-                <a:solidFill>
-                  <a:srgbClr val="23283A"/>
-                </a:solidFill>
-                <a:latin typeface="Arial" pitchFamily="34" charset="0"/>
-                <a:ea typeface="Arial" pitchFamily="34" charset="-122"/>
-                <a:cs typeface="Arial" pitchFamily="34" charset="-120"/>
-              </a:rPr>
-              <a:t>Isi email akurat, bukan halusinasi Claude</a:t>
-            </a:r>
-            <a:endParaRPr lang="en-US" sz="1100" dirty="0"/>
-          </a:p>
-        </p:txBody>
-      </p:sp>
-      <p:sp>
-        <p:nvSpPr>
-          <p:cNvPr id="19" name="Shape 17"/>
-          <p:cNvSpPr/>
-          <p:nvPr/>
-        </p:nvSpPr>
-        <p:spPr>
-          <a:xfrm>
-            <a:off x="6236208" y="2944368"/>
-            <a:ext cx="182880" cy="182880"/>
-          </a:xfrm>
-          <a:prstGeom prst="rect">
-            <a:avLst/>
-          </a:prstGeom>
-          <a:solidFill>
-            <a:srgbClr val="1A7A44"/>
-          </a:solidFill>
-          <a:ln w="12700">
-            <a:solidFill>
-              <a:srgbClr val="1A7A44"/>
-            </a:solidFill>
-            <a:prstDash val="solid"/>
-          </a:ln>
-        </p:spPr>
-      </p:sp>
-      <p:sp>
-        <p:nvSpPr>
-          <p:cNvPr id="20" name="Text 18"/>
-          <p:cNvSpPr/>
-          <p:nvPr/>
-        </p:nvSpPr>
-        <p:spPr>
-          <a:xfrm>
-            <a:off x="6236208" y="2926080"/>
-            <a:ext cx="182880" cy="182880"/>
-          </a:xfrm>
-          <a:prstGeom prst="rect">
-            <a:avLst/>
-          </a:prstGeom>
-          <a:noFill/>
-          <a:ln/>
-        </p:spPr>
-        <p:txBody>
-          <a:bodyPr wrap="square" lIns="0" tIns="0" rIns="0" bIns="0" rtlCol="0" anchor="ctr"/>
-          <a:lstStyle/>
-          <a:p>
-            <a:pPr algn="ctr" indent="0" marL="0">
-              <a:buNone/>
-            </a:pPr>
-            <a:r>
-              <a:rPr lang="en-US" sz="1000" b="1" dirty="0">
-                <a:solidFill>
-                  <a:srgbClr val="FFFFFF"/>
-                </a:solidFill>
-                <a:latin typeface="Arial" pitchFamily="34" charset="0"/>
-                <a:ea typeface="Arial" pitchFamily="34" charset="-122"/>
-                <a:cs typeface="Arial" pitchFamily="34" charset="-120"/>
-              </a:rPr>
-              <a:t>v</a:t>
-            </a:r>
-            <a:endParaRPr lang="en-US" sz="1000" dirty="0"/>
-          </a:p>
-        </p:txBody>
-      </p:sp>
-      <p:sp>
-        <p:nvSpPr>
-          <p:cNvPr id="21" name="Text 19"/>
-          <p:cNvSpPr/>
-          <p:nvPr/>
-        </p:nvSpPr>
-        <p:spPr>
-          <a:xfrm>
-            <a:off x="6492240" y="2898648"/>
-            <a:ext cx="5074920" cy="310896"/>
-          </a:xfrm>
-          <a:prstGeom prst="rect">
-            <a:avLst/>
-          </a:prstGeom>
-          <a:noFill/>
-          <a:ln/>
-        </p:spPr>
-        <p:txBody>
-          <a:bodyPr wrap="square" lIns="0" tIns="0" rIns="0" bIns="0" rtlCol="0" anchor="ctr"/>
-          <a:lstStyle/>
-          <a:p>
-            <a:pPr indent="0" marL="0">
-              <a:buNone/>
-            </a:pPr>
-            <a:r>
-              <a:rPr lang="en-US" sz="1100" dirty="0">
-                <a:solidFill>
-                  <a:srgbClr val="23283A"/>
-                </a:solidFill>
-                <a:latin typeface="Arial" pitchFamily="34" charset="0"/>
-                <a:ea typeface="Arial" pitchFamily="34" charset="-122"/>
-                <a:cs typeface="Arial" pitchFamily="34" charset="-120"/>
-              </a:rPr>
-              <a:t>Tidak ada info sensitif yang ikut di-paste ke Claude</a:t>
-            </a:r>
-            <a:endParaRPr lang="en-US" sz="1100" dirty="0"/>
-          </a:p>
-        </p:txBody>
-      </p:sp>
-      <p:sp>
-        <p:nvSpPr>
-          <p:cNvPr id="22" name="Shape 20"/>
-          <p:cNvSpPr/>
-          <p:nvPr/>
-        </p:nvSpPr>
-        <p:spPr>
-          <a:xfrm>
-            <a:off x="749808" y="3364992"/>
-            <a:ext cx="182880" cy="182880"/>
-          </a:xfrm>
-          <a:prstGeom prst="rect">
-            <a:avLst/>
-          </a:prstGeom>
-          <a:solidFill>
-            <a:srgbClr val="1A7A44"/>
-          </a:solidFill>
-          <a:ln w="12700">
-            <a:solidFill>
-              <a:srgbClr val="1A7A44"/>
-            </a:solidFill>
-            <a:prstDash val="solid"/>
-          </a:ln>
-        </p:spPr>
-      </p:sp>
-      <p:sp>
-        <p:nvSpPr>
-          <p:cNvPr id="23" name="Text 21"/>
-          <p:cNvSpPr/>
-          <p:nvPr/>
-        </p:nvSpPr>
-        <p:spPr>
-          <a:xfrm>
-            <a:off x="749808" y="3346704"/>
-            <a:ext cx="182880" cy="182880"/>
-          </a:xfrm>
-          <a:prstGeom prst="rect">
-            <a:avLst/>
-          </a:prstGeom>
-          <a:noFill/>
-          <a:ln/>
-        </p:spPr>
-        <p:txBody>
-          <a:bodyPr wrap="square" lIns="0" tIns="0" rIns="0" bIns="0" rtlCol="0" anchor="ctr"/>
-          <a:lstStyle/>
-          <a:p>
-            <a:pPr algn="ctr" indent="0" marL="0">
-              <a:buNone/>
-            </a:pPr>
-            <a:r>
-              <a:rPr lang="en-US" sz="1000" b="1" dirty="0">
-                <a:solidFill>
-                  <a:srgbClr val="FFFFFF"/>
-                </a:solidFill>
-                <a:latin typeface="Arial" pitchFamily="34" charset="0"/>
-                <a:ea typeface="Arial" pitchFamily="34" charset="-122"/>
-                <a:cs typeface="Arial" pitchFamily="34" charset="-120"/>
-              </a:rPr>
-              <a:t>v</a:t>
-            </a:r>
-            <a:endParaRPr lang="en-US" sz="1000" dirty="0"/>
-          </a:p>
-        </p:txBody>
-      </p:sp>
-      <p:sp>
-        <p:nvSpPr>
-          <p:cNvPr id="24" name="Text 22"/>
-          <p:cNvSpPr/>
-          <p:nvPr/>
-        </p:nvSpPr>
-        <p:spPr>
-          <a:xfrm>
-            <a:off x="1005840" y="3319272"/>
-            <a:ext cx="5074920" cy="310896"/>
-          </a:xfrm>
-          <a:prstGeom prst="rect">
-            <a:avLst/>
-          </a:prstGeom>
-          <a:noFill/>
-          <a:ln/>
-        </p:spPr>
-        <p:txBody>
-          <a:bodyPr wrap="square" lIns="0" tIns="0" rIns="0" bIns="0" rtlCol="0" anchor="ctr"/>
-          <a:lstStyle/>
-          <a:p>
-            <a:pPr indent="0" marL="0">
-              <a:buNone/>
-            </a:pPr>
-            <a:r>
-              <a:rPr lang="en-US" sz="1100" dirty="0">
-                <a:solidFill>
-                  <a:srgbClr val="23283A"/>
-                </a:solidFill>
-                <a:latin typeface="Arial" pitchFamily="34" charset="0"/>
-                <a:ea typeface="Arial" pitchFamily="34" charset="-122"/>
-                <a:cs typeface="Arial" pitchFamily="34" charset="-120"/>
-              </a:rPr>
-              <a:t>Ada CTA yang jelas jika diperlukan</a:t>
-            </a:r>
-            <a:endParaRPr lang="en-US" sz="1100" dirty="0"/>
-          </a:p>
-        </p:txBody>
-      </p:sp>
-      <p:sp>
-        <p:nvSpPr>
-          <p:cNvPr id="25" name="Shape 23"/>
-          <p:cNvSpPr/>
-          <p:nvPr/>
-        </p:nvSpPr>
-        <p:spPr>
-          <a:xfrm>
-            <a:off x="6236208" y="3364992"/>
-            <a:ext cx="182880" cy="182880"/>
-          </a:xfrm>
-          <a:prstGeom prst="rect">
-            <a:avLst/>
-          </a:prstGeom>
-          <a:solidFill>
-            <a:srgbClr val="1A7A44"/>
-          </a:solidFill>
-          <a:ln w="12700">
-            <a:solidFill>
-              <a:srgbClr val="1A7A44"/>
-            </a:solidFill>
-            <a:prstDash val="solid"/>
-          </a:ln>
-        </p:spPr>
-      </p:sp>
-      <p:sp>
-        <p:nvSpPr>
-          <p:cNvPr id="26" name="Text 24"/>
-          <p:cNvSpPr/>
-          <p:nvPr/>
-        </p:nvSpPr>
-        <p:spPr>
-          <a:xfrm>
-            <a:off x="6236208" y="3346704"/>
-            <a:ext cx="182880" cy="182880"/>
-          </a:xfrm>
-          <a:prstGeom prst="rect">
-            <a:avLst/>
-          </a:prstGeom>
-          <a:noFill/>
-          <a:ln/>
-        </p:spPr>
-        <p:txBody>
-          <a:bodyPr wrap="square" lIns="0" tIns="0" rIns="0" bIns="0" rtlCol="0" anchor="ctr"/>
-          <a:lstStyle/>
-          <a:p>
-            <a:pPr algn="ctr" indent="0" marL="0">
-              <a:buNone/>
-            </a:pPr>
-            <a:r>
-              <a:rPr lang="en-US" sz="1000" b="1" dirty="0">
-                <a:solidFill>
-                  <a:srgbClr val="FFFFFF"/>
-                </a:solidFill>
-                <a:latin typeface="Arial" pitchFamily="34" charset="0"/>
-                <a:ea typeface="Arial" pitchFamily="34" charset="-122"/>
-                <a:cs typeface="Arial" pitchFamily="34" charset="-120"/>
-              </a:rPr>
-              <a:t>v</a:t>
-            </a:r>
-            <a:endParaRPr lang="en-US" sz="1000" dirty="0"/>
-          </a:p>
-        </p:txBody>
-      </p:sp>
-      <p:sp>
-        <p:nvSpPr>
-          <p:cNvPr id="27" name="Text 25"/>
-          <p:cNvSpPr/>
-          <p:nvPr/>
-        </p:nvSpPr>
-        <p:spPr>
-          <a:xfrm>
-            <a:off x="6492240" y="3319272"/>
-            <a:ext cx="5074920" cy="310896"/>
-          </a:xfrm>
-          <a:prstGeom prst="rect">
-            <a:avLst/>
-          </a:prstGeom>
-          <a:noFill/>
-          <a:ln/>
-        </p:spPr>
-        <p:txBody>
-          <a:bodyPr wrap="square" lIns="0" tIns="0" rIns="0" bIns="0" rtlCol="0" anchor="ctr"/>
-          <a:lstStyle/>
-          <a:p>
-            <a:pPr indent="0" marL="0">
-              <a:buNone/>
-            </a:pPr>
-            <a:r>
-              <a:rPr lang="en-US" sz="1100" dirty="0">
-                <a:solidFill>
-                  <a:srgbClr val="23283A"/>
-                </a:solidFill>
-                <a:latin typeface="Arial" pitchFamily="34" charset="0"/>
-                <a:ea typeface="Arial" pitchFamily="34" charset="-122"/>
-                <a:cs typeface="Arial" pitchFamily="34" charset="-120"/>
-              </a:rPr>
-              <a:t>Panjang sudah sesuai, tidak bertele-tele</a:t>
-            </a:r>
-            <a:endParaRPr lang="en-US" sz="1100" dirty="0"/>
-          </a:p>
-        </p:txBody>
-      </p:sp>
-      <p:sp>
-        <p:nvSpPr>
-          <p:cNvPr id="28" name="Shape 26"/>
-          <p:cNvSpPr/>
-          <p:nvPr/>
-        </p:nvSpPr>
-        <p:spPr>
-          <a:xfrm>
-            <a:off x="502920" y="3886200"/>
-            <a:ext cx="11155680" cy="402336"/>
+                <a:latin typeface="Helvetica" pitchFamily="34" charset="0"/>
+                <a:ea typeface="Helvetica" pitchFamily="34" charset="-122"/>
+                <a:cs typeface="Helvetica" pitchFamily="34" charset="-120"/>
+              </a:rPr>
+              <a:t>•  Gmail MCP — hubungkan Claude langsung ke inbox Gmail kamu untuk workflow yang lebih cepat. Setup di akhir sesi.</a:t>
+            </a:r>
+            <a:endParaRPr lang="en-US" sz="1200" dirty="0"/>
+          </a:p>
+        </p:txBody>
+      </p:sp>
+      <p:sp>
+        <p:nvSpPr>
+          <p:cNvPr id="14" name="Shape 12"/>
+          <p:cNvSpPr/>
+          <p:nvPr/>
+        </p:nvSpPr>
+        <p:spPr>
+          <a:xfrm>
+            <a:off x="548640" y="4556455"/>
+            <a:ext cx="11094415" cy="1480376"/>
           </a:xfrm>
           <a:prstGeom prst="roundRect">
             <a:avLst>
-              <a:gd name="adj" fmla="val 18182"/>
-            </a:avLst>
-          </a:prstGeom>
-          <a:solidFill>
-            <a:srgbClr val="141D33"/>
-          </a:solidFill>
-          <a:ln w="12700">
-            <a:solidFill>
-              <a:srgbClr val="6849F6"/>
-            </a:solidFill>
-            <a:prstDash val="solid"/>
-          </a:ln>
-        </p:spPr>
-      </p:sp>
-      <p:sp>
-        <p:nvSpPr>
-          <p:cNvPr id="29" name="Text 27"/>
-          <p:cNvSpPr/>
-          <p:nvPr/>
-        </p:nvSpPr>
-        <p:spPr>
-          <a:xfrm>
-            <a:off x="749808" y="3886200"/>
-            <a:ext cx="10698480" cy="402336"/>
-          </a:xfrm>
-          <a:prstGeom prst="rect">
-            <a:avLst/>
-          </a:prstGeom>
-          <a:noFill/>
-          <a:ln/>
-        </p:spPr>
-        <p:txBody>
-          <a:bodyPr wrap="square" lIns="0" tIns="0" rIns="0" bIns="0" rtlCol="0" anchor="ctr"/>
-          <a:lstStyle/>
-          <a:p>
-            <a:pPr indent="0" marL="0">
-              <a:buNone/>
-            </a:pPr>
-            <a:r>
-              <a:rPr lang="en-US" sz="1150" dirty="0">
-                <a:solidFill>
-                  <a:srgbClr val="FFFFFF"/>
-                </a:solidFill>
-                <a:latin typeface="Arial" pitchFamily="34" charset="0"/>
-                <a:ea typeface="Arial" pitchFamily="34" charset="-122"/>
-                <a:cs typeface="Arial" pitchFamily="34" charset="-120"/>
-              </a:rPr>
-              <a:t>BONUS: Gmail MCP — hubungkan Claude langsung ke inbox Gmail kamu untuk workflow yang lebih cepat. Setup di akhir sesi.</a:t>
-            </a:r>
-            <a:endParaRPr lang="en-US" sz="1150" dirty="0"/>
-          </a:p>
-        </p:txBody>
-      </p:sp>
-      <p:sp>
-        <p:nvSpPr>
-          <p:cNvPr id="30" name="Shape 28"/>
-          <p:cNvSpPr/>
-          <p:nvPr/>
-        </p:nvSpPr>
-        <p:spPr>
-          <a:xfrm>
-            <a:off x="502920" y="4398264"/>
-            <a:ext cx="11155680" cy="2002536"/>
-          </a:xfrm>
-          <a:prstGeom prst="roundRect">
-            <a:avLst>
-              <a:gd name="adj" fmla="val 5479"/>
+              <a:gd name="adj" fmla="val 6177"/>
             </a:avLst>
           </a:prstGeom>
           <a:solidFill>
@@ -4885,14 +4346,14 @@
       </p:sp>
       <p:sp>
         <p:nvSpPr>
-          <p:cNvPr id="31" name="Text 29"/>
-          <p:cNvSpPr/>
-          <p:nvPr/>
-        </p:nvSpPr>
-        <p:spPr>
-          <a:xfrm>
-            <a:off x="749808" y="4535424"/>
-            <a:ext cx="3657600" cy="274320"/>
+          <p:cNvPr id="15" name="Text 13"/>
+          <p:cNvSpPr/>
+          <p:nvPr/>
+        </p:nvSpPr>
+        <p:spPr>
+          <a:xfrm>
+            <a:off x="749808" y="4757623"/>
+            <a:ext cx="10692079" cy="274320"/>
           </a:xfrm>
           <a:prstGeom prst="rect">
             <a:avLst/>
@@ -4908,15 +4369,15 @@
               <a:buNone/>
             </a:pPr>
             <a:r>
-              <a:rPr lang="en-US" sz="1250" b="1" dirty="0">
+              <a:rPr lang="en-US" sz="1250" b="1" spc="30" kern="0" dirty="0">
                 <a:solidFill>
                   <a:srgbClr val="1A7A44"/>
                 </a:solidFill>
-                <a:latin typeface="Arial" pitchFamily="34" charset="0"/>
-                <a:ea typeface="Arial" pitchFamily="34" charset="-122"/>
-                <a:cs typeface="Arial" pitchFamily="34" charset="-120"/>
-              </a:rPr>
-              <a:t>LATIHAN</a:t>
+                <a:latin typeface="Helvetica" pitchFamily="34" charset="0"/>
+                <a:ea typeface="Helvetica" pitchFamily="34" charset="-122"/>
+                <a:cs typeface="Helvetica" pitchFamily="34" charset="-120"/>
+              </a:rPr>
+              <a:t>■  LATIHAN</a:t>
             </a:r>
             <a:endParaRPr lang="en-US" sz="1250" dirty="0"/>
           </a:p>
@@ -4924,26 +4385,29 @@
       </p:sp>
       <p:sp>
         <p:nvSpPr>
-          <p:cNvPr id="32" name="Text 30"/>
-          <p:cNvSpPr/>
-          <p:nvPr/>
-        </p:nvSpPr>
-        <p:spPr>
-          <a:xfrm>
-            <a:off x="749808" y="4855464"/>
-            <a:ext cx="10652760" cy="274320"/>
-          </a:xfrm>
-          <a:prstGeom prst="rect">
-            <a:avLst/>
-          </a:prstGeom>
-          <a:noFill/>
-          <a:ln/>
-        </p:spPr>
-        <p:txBody>
-          <a:bodyPr wrap="square" lIns="0" tIns="0" rIns="0" bIns="0" rtlCol="0" anchor="ctr"/>
-          <a:lstStyle/>
-          <a:p>
-            <a:pPr indent="0" marL="0">
+          <p:cNvPr id="16" name="Text 14"/>
+          <p:cNvSpPr/>
+          <p:nvPr/>
+        </p:nvSpPr>
+        <p:spPr>
+          <a:xfrm>
+            <a:off x="749808" y="5105095"/>
+            <a:ext cx="10692079" cy="730568"/>
+          </a:xfrm>
+          <a:prstGeom prst="rect">
+            <a:avLst/>
+          </a:prstGeom>
+          <a:noFill/>
+          <a:ln/>
+        </p:spPr>
+        <p:txBody>
+          <a:bodyPr wrap="square" lIns="0" tIns="0" rIns="0" bIns="0" rtlCol="0" anchor="t"/>
+          <a:lstStyle/>
+          <a:p>
+            <a:pPr indent="0" marL="0">
+              <a:lnSpc>
+                <a:spcPct val="130000"/>
+              </a:lnSpc>
               <a:buNone/>
             </a:pPr>
             <a:r>
@@ -4951,133 +4415,11 @@
                 <a:solidFill>
                   <a:srgbClr val="23283A"/>
                 </a:solidFill>
-                <a:latin typeface="Arial" pitchFamily="34" charset="0"/>
-                <a:ea typeface="Arial" pitchFamily="34" charset="-122"/>
-                <a:cs typeface="Arial" pitchFamily="34" charset="-120"/>
-              </a:rPr>
-              <a:t>Buka inbox. Pilih 1 email belum dibalas.</a:t>
-            </a:r>
-            <a:endParaRPr lang="en-US" sz="1250" dirty="0"/>
-          </a:p>
-        </p:txBody>
-      </p:sp>
-      <p:sp>
-        <p:nvSpPr>
-          <p:cNvPr id="33" name="Text 31"/>
-          <p:cNvSpPr/>
-          <p:nvPr/>
-        </p:nvSpPr>
-        <p:spPr>
-          <a:xfrm>
-            <a:off x="749808" y="5184648"/>
-            <a:ext cx="10652760" cy="1115568"/>
-          </a:xfrm>
-          <a:prstGeom prst="rect">
-            <a:avLst/>
-          </a:prstGeom>
-          <a:noFill/>
-          <a:ln/>
-        </p:spPr>
-        <p:txBody>
-          <a:bodyPr wrap="square" lIns="0" tIns="0" rIns="0" bIns="0" rtlCol="0" anchor="t"/>
-          <a:lstStyle/>
-          <a:p>
-            <a:pPr indent="0" marL="0">
-              <a:lnSpc>
-                <a:spcPct val="115000"/>
-              </a:lnSpc>
-              <a:buNone/>
-            </a:pPr>
-            <a:r>
-              <a:rPr lang="en-US" sz="1250" dirty="0">
-                <a:solidFill>
-                  <a:srgbClr val="23283A"/>
-                </a:solidFill>
-                <a:latin typeface="Arial" pitchFamily="34" charset="0"/>
-                <a:ea typeface="Arial" pitchFamily="34" charset="-122"/>
-                <a:cs typeface="Arial" pitchFamily="34" charset="-120"/>
-              </a:rPr>
-              <a:t>1. Identifikasi tipe: inquiry / komplain / follow-up / konfirmasi</a:t>
-            </a:r>
-            <a:endParaRPr lang="en-US" sz="1250" dirty="0"/>
-          </a:p>
-          <a:p>
-            <a:pPr indent="0" marL="0">
-              <a:lnSpc>
-                <a:spcPct val="115000"/>
-              </a:lnSpc>
-              <a:buNone/>
-            </a:pPr>
-            <a:r>
-              <a:rPr lang="en-US" sz="1250" dirty="0">
-                <a:solidFill>
-                  <a:srgbClr val="23283A"/>
-                </a:solidFill>
-                <a:latin typeface="Arial" pitchFamily="34" charset="0"/>
-                <a:ea typeface="Arial" pitchFamily="34" charset="-122"/>
-                <a:cs typeface="Arial" pitchFamily="34" charset="-120"/>
-              </a:rPr>
-              <a:t>2. Pilih template dari slide sebelumnya dan isi [placeholder] dengan info nyata</a:t>
-            </a:r>
-            <a:endParaRPr lang="en-US" sz="1250" dirty="0"/>
-          </a:p>
-          <a:p>
-            <a:pPr indent="0" marL="0">
-              <a:lnSpc>
-                <a:spcPct val="115000"/>
-              </a:lnSpc>
-              <a:buNone/>
-            </a:pPr>
-            <a:r>
-              <a:rPr lang="en-US" sz="1250" dirty="0">
-                <a:solidFill>
-                  <a:srgbClr val="23283A"/>
-                </a:solidFill>
-                <a:latin typeface="Arial" pitchFamily="34" charset="0"/>
-                <a:ea typeface="Arial" pitchFamily="34" charset="-122"/>
-                <a:cs typeface="Arial" pitchFamily="34" charset="-120"/>
-              </a:rPr>
-              <a:t>3. Paste ke Claude, baca output, edit seperlunya, lalu kirim</a:t>
-            </a:r>
-            <a:endParaRPr lang="en-US" sz="1250" dirty="0"/>
-          </a:p>
-          <a:p>
-            <a:pPr indent="0" marL="0">
-              <a:lnSpc>
-                <a:spcPct val="115000"/>
-              </a:lnSpc>
-              <a:buNone/>
-            </a:pPr>
-            <a:r>
-              <a:rPr lang="en-US" sz="1250" dirty="0">
-                <a:solidFill>
-                  <a:srgbClr val="23283A"/>
-                </a:solidFill>
-                <a:latin typeface="Arial" pitchFamily="34" charset="0"/>
-                <a:ea typeface="Arial" pitchFamily="34" charset="-122"/>
-                <a:cs typeface="Arial" pitchFamily="34" charset="-120"/>
-              </a:rPr>
-              <a:t> </a:t>
-            </a:r>
-            <a:endParaRPr lang="en-US" sz="1250" dirty="0"/>
-          </a:p>
-          <a:p>
-            <a:pPr indent="0" marL="0">
-              <a:lnSpc>
-                <a:spcPct val="115000"/>
-              </a:lnSpc>
-              <a:buNone/>
-            </a:pPr>
-            <a:r>
-              <a:rPr lang="en-US" sz="1250" b="1" dirty="0">
-                <a:solidFill>
-                  <a:srgbClr val="23283A"/>
-                </a:solidFill>
-                <a:latin typeface="Arial" pitchFamily="34" charset="0"/>
-                <a:ea typeface="Arial" pitchFamily="34" charset="-122"/>
-                <a:cs typeface="Arial" pitchFamily="34" charset="-120"/>
-              </a:rPr>
-              <a:t>Output: 1 email terkirim hari ini menggunakan Claude.</a:t>
+                <a:latin typeface="Helvetica" pitchFamily="34" charset="0"/>
+                <a:ea typeface="Helvetica" pitchFamily="34" charset="-122"/>
+                <a:cs typeface="Helvetica" pitchFamily="34" charset="-120"/>
+              </a:rPr>
+              <a:t>Buka inbox, pilih 1 email belum dibalas: (1) Identifikasi tipe: inquiry / komplain / follow-up / konfirmasi, (2) Pilih template dari slide sebelumnya dan isi [placeholder] dengan info nyata, (3) Paste ke Claude, baca output, edit seperlunya, lalu kirim. Output: 1 email terkirim hari ini menggunakan Claude.</a:t>
             </a:r>
             <a:endParaRPr lang="en-US" sz="1250" dirty="0"/>
           </a:p>

</xml_diff>

<commit_message>
K2 M3: remove Rina-specific intro (generic Gmail+Claude framing); shrink MCP connector bonus to brief mention; latihan now uses k2-m3-contoh-inbox.txt with own-inbox follow-up
</commit_message>
<xml_diff>
--- a/K2-Produktivitas/M03-Gmail-Claude/K2-M03-Gmail-Claude.pptx
+++ b/K2-Produktivitas/M03-Gmail-Claude/K2-M03-Gmail-Claude.pptx
@@ -4400,7 +4400,7 @@
                 <a:ea typeface="Helvetica" pitchFamily="34" charset="-122"/>
                 <a:cs typeface="Helvetica" pitchFamily="34" charset="-120"/>
               </a:rPr>
-              <a:t>•  Gmail MCP — hubungkan Claude langsung ke inbox Gmail kamu untuk workflow yang lebih cepat. Setup di akhir sesi.</a:t>
+              <a:t>•  Gmail MCP — hubungkan Claude langsung ke inbox Gmail kamu, baca &amp; draft tanpa copy-paste. Detail setup dibahas di modul lain.</a:t>
             </a:r>
             <a:endParaRPr lang="en-US" sz="1200" dirty="0"/>
           </a:p>
@@ -4508,7 +4508,7 @@
                 <a:ea typeface="Helvetica" pitchFamily="34" charset="-122"/>
                 <a:cs typeface="Helvetica" pitchFamily="34" charset="-120"/>
               </a:rPr>
-              <a:t>Buka inbox, pilih 1 email belum dibalas: (1) Identifikasi tipe: inquiry / komplain / follow-up / konfirmasi, (2) Pilih template dari slide sebelumnya dan isi [placeholder] dengan info nyata, (3) Paste ke Claude, baca output, edit seperlunya, lalu kirim. Output: 1 email terkirim hari ini menggunakan Claude.</a:t>
+              <a:t>Download file k2-m3-contoh-inbox.txt, pilih 1 email: (1) Identifikasi tipe: inquiry / komplain / follow-up / konfirmasi, (2) Pilih template dari slide sebelumnya dan isi [placeholder] dengan info dari email, (3) Paste ke Claude, baca output, edit seperlunya. Lanjutkan dengan email asli dari inbox kamu sendiri.</a:t>
             </a:r>
             <a:endParaRPr lang="en-US" sz="1250" dirty="0"/>
           </a:p>

</xml_diff>

<commit_message>
K2 M3: fix PPT latihan email count (1->3) and Contoh Prompt text to match HTML/PDF; align Level Up section structure (Kapan Dipakai label) across all formats; move MCP Connector bonus to bottom in HTML/PDF
</commit_message>
<xml_diff>
--- a/K2-Produktivitas/M03-Gmail-Claude/K2-M03-Gmail-Claude.pptx
+++ b/K2-Produktivitas/M03-Gmail-Claude/K2-M03-Gmail-Claude.pptx
@@ -4508,7 +4508,7 @@
                 <a:ea typeface="Helvetica" pitchFamily="34" charset="-122"/>
                 <a:cs typeface="Helvetica" pitchFamily="34" charset="-120"/>
               </a:rPr>
-              <a:t>Download file k2-m3-contoh-inbox.txt, pilih 1 email: (1) Identifikasi tipe: inquiry / komplain / follow-up / konfirmasi, (2) Pilih template dari slide sebelumnya dan isi [placeholder] dengan info dari email, (3) Paste ke Claude, baca output, edit seperlunya. Lanjutkan dengan email asli dari inbox kamu sendiri.</a:t>
+              <a:t>Download file k2-m3-contoh-inbox.txt, pilih 3 email dengan tipe berbeda: (1) Identifikasi tipe: inquiry / komplain / follow-up / konfirmasi, (2) Pilih template dari slide sebelumnya dan isi [placeholder] dengan info dari email, (3) Paste ke Claude, baca output, edit seperlunya. Lanjutkan dengan email asli dari inbox kamu sendiri.</a:t>
             </a:r>
             <a:endParaRPr lang="en-US" sz="1250" dirty="0"/>
           </a:p>
@@ -4873,11 +4873,11 @@
         <p:spPr>
           <a:xfrm>
             <a:off x="548640" y="3586861"/>
-            <a:ext cx="11094415" cy="1214984"/>
+            <a:ext cx="11094415" cy="1429283"/>
           </a:xfrm>
           <a:prstGeom prst="roundRect">
             <a:avLst>
-              <a:gd name="adj" fmla="val 7526"/>
+              <a:gd name="adj" fmla="val 6398"/>
             </a:avLst>
           </a:prstGeom>
           <a:solidFill>
@@ -4939,7 +4939,7 @@
         <p:spPr>
           <a:xfrm>
             <a:off x="768096" y="4153789"/>
-            <a:ext cx="10655503" cy="428600"/>
+            <a:ext cx="10655503" cy="642899"/>
           </a:xfrm>
           <a:prstGeom prst="rect">
             <a:avLst/>
@@ -4966,7 +4966,7 @@
                 <a:ea typeface="Helvetica" pitchFamily="34" charset="-122"/>
                 <a:cs typeface="Helvetica" pitchFamily="34" charset="-120"/>
               </a:rPr>
-              <a:t>[paste isi inbox] Kelompokkan semua email ini ke 3 kategori: URGENT (perlu dibalas hari ini), PERLU DIBALAS (bisa besok), SEKADAR INFO (tidak perlu balasan). Buatkan sebagai 1 halaman HTML dengan 3 kolom berwarna berbeda, supaya saya bisa lihat sekilas mana yang harus dikerjakan duluan.</a:t>
+              <a:t>[paste k2-m3-contoh-inbox.txt atau minta Claude cek inbox via Gmail Connector] Kelompokkan semua email ini ke 3 kategori: URGENT (perlu dibalas hari ini), PERLU DIBALAS (bisa besok), SEKADAR INFO (tidak perlu balasan). Untuk tiap email, tulis ringkasan 1 kalimat. Buatkan sebagai 1 halaman HTML dengan 3 kolom berwarna berbeda, supaya saya bisa lihat sekilas mana yang harus dikerjakan duluan.</a:t>
             </a:r>
             <a:endParaRPr lang="en-US" sz="1100" dirty="0"/>
           </a:p>

</xml_diff>

<commit_message>
K2 M3: revert PPT latihan back to 1 email / original Contoh Prompt wording; update HTML+PDF to follow PPT's original wording instead
</commit_message>
<xml_diff>
--- a/K2-Produktivitas/M03-Gmail-Claude/K2-M03-Gmail-Claude.pptx
+++ b/K2-Produktivitas/M03-Gmail-Claude/K2-M03-Gmail-Claude.pptx
@@ -4508,7 +4508,7 @@
                 <a:ea typeface="Helvetica" pitchFamily="34" charset="-122"/>
                 <a:cs typeface="Helvetica" pitchFamily="34" charset="-120"/>
               </a:rPr>
-              <a:t>Download file k2-m3-contoh-inbox.txt, pilih 3 email dengan tipe berbeda: (1) Identifikasi tipe: inquiry / komplain / follow-up / konfirmasi, (2) Pilih template dari slide sebelumnya dan isi [placeholder] dengan info dari email, (3) Paste ke Claude, baca output, edit seperlunya. Lanjutkan dengan email asli dari inbox kamu sendiri.</a:t>
+              <a:t>Download file k2-m3-contoh-inbox.txt, pilih 1 email: (1) Identifikasi tipe: inquiry / komplain / follow-up / konfirmasi, (2) Pilih template dari slide sebelumnya dan isi [placeholder] dengan info dari email, (3) Paste ke Claude, baca output, edit seperlunya. Lanjutkan dengan email asli dari inbox kamu sendiri.</a:t>
             </a:r>
             <a:endParaRPr lang="en-US" sz="1250" dirty="0"/>
           </a:p>
@@ -4873,11 +4873,11 @@
         <p:spPr>
           <a:xfrm>
             <a:off x="548640" y="3586861"/>
-            <a:ext cx="11094415" cy="1429283"/>
+            <a:ext cx="11094415" cy="1214984"/>
           </a:xfrm>
           <a:prstGeom prst="roundRect">
             <a:avLst>
-              <a:gd name="adj" fmla="val 6398"/>
+              <a:gd name="adj" fmla="val 7526"/>
             </a:avLst>
           </a:prstGeom>
           <a:solidFill>
@@ -4939,7 +4939,7 @@
         <p:spPr>
           <a:xfrm>
             <a:off x="768096" y="4153789"/>
-            <a:ext cx="10655503" cy="642899"/>
+            <a:ext cx="10655503" cy="428600"/>
           </a:xfrm>
           <a:prstGeom prst="rect">
             <a:avLst/>
@@ -4966,7 +4966,7 @@
                 <a:ea typeface="Helvetica" pitchFamily="34" charset="-122"/>
                 <a:cs typeface="Helvetica" pitchFamily="34" charset="-120"/>
               </a:rPr>
-              <a:t>[paste k2-m3-contoh-inbox.txt atau minta Claude cek inbox via Gmail Connector] Kelompokkan semua email ini ke 3 kategori: URGENT (perlu dibalas hari ini), PERLU DIBALAS (bisa besok), SEKADAR INFO (tidak perlu balasan). Untuk tiap email, tulis ringkasan 1 kalimat. Buatkan sebagai 1 halaman HTML dengan 3 kolom berwarna berbeda, supaya saya bisa lihat sekilas mana yang harus dikerjakan duluan.</a:t>
+              <a:t>[paste isi inbox] Kelompokkan semua email ini ke 3 kategori: URGENT (perlu dibalas hari ini), PERLU DIBALAS (bisa besok), SEKADAR INFO (tidak perlu balasan). Buatkan sebagai 1 halaman HTML dengan 3 kolom berwarna berbeda, supaya saya bisa lihat sekilas mana yang harus dikerjakan duluan.</a:t>
             </a:r>
             <a:endParaRPr lang="en-US" sz="1100" dirty="0"/>
           </a:p>

</xml_diff>